<commit_message>
Slajd ze stackiem technologicznym
Drugi slajd w talii: sześć kategorii w siatce (język i narzędzia, frontend,
backend, dane, formaty i integracje, uruchomienie) plus pas ze świadomymi
pominięciami — WebSockety, Redis, mikroserwisy, integracje zewnętrzne — wraz
z uzasadnieniem każdego z nich.

Wersje wzięte z package.json, .nvmrc i plików docker, nie z pamięci.
Układ celowo inny niż na slajdzie architektury (siatka zamiast przepływu),
motyw znaczników i paleta wspólne.

Co-Authored-By: Claude Opus 5 <noreply@anthropic.com>
</commit_message>
<xml_diff>
--- a/Architektura - aplikacja nieobecnosci.pptx
+++ b/Architektura - aplikacja nieobecnosci.pptx
@@ -6,9 +6,10 @@
   </p:sldMasterIdLst>
   <p:sldIdLst>
     <p:sldId id="256" r:id="rId2"/>
+    <p:sldId id="257" r:id="rId3"/>
   </p:sldIdLst>
   <p:notesMasterIdLst>
-    <p:notesMasterId r:id="rId3"/>
+    <p:notesMasterId r:id="rId4"/>
   </p:notesMasterIdLst>
   <p:sldSz cx="12192000" cy="6858000"/>
   <p:notesSz cx="6858000" cy="12192000"/>
@@ -526,6 +527,94 @@
             <a:fld id="{F7021451-1387-4CA6-816F-3879F97B5CBC}" type="slidenum">
               <a:rPr lang="en-US"/>
               <a:t>1</a:t>
+            </a:fld>
+            <a:endParaRPr lang="en-US"/>
+          </a:p>
+        </p:txBody>
+      </p:sp>
+    </p:spTree>
+    <p:extLst>
+      <p:ext uri="{BB962C8B-B14F-4D97-AF65-F5344CB8AC3E}">
+        <p14:creationId xmlns:p14="http://schemas.microsoft.com/office/powerpoint/2010/main" val="1024086991"/>
+      </p:ext>
+    </p:extLst>
+  </p:cSld>
+  <p:clrMapOvr>
+    <a:masterClrMapping/>
+  </p:clrMapOvr>
+</p:notes>
+</file>
+
+<file path=ppt/notesSlides/notesSlide2.xml><?xml version="1.0" encoding="utf-8"?>
+<p:notes xmlns:a="http://schemas.openxmlformats.org/drawingml/2006/main" xmlns:r="http://schemas.openxmlformats.org/officeDocument/2006/relationships" xmlns:p="http://schemas.openxmlformats.org/presentationml/2006/main">
+  <p:cSld>
+    <p:spTree>
+      <p:nvGrpSpPr>
+        <p:cNvPr id="1" name=""/>
+        <p:cNvGrpSpPr/>
+        <p:nvPr/>
+      </p:nvGrpSpPr>
+      <p:grpSpPr>
+        <a:xfrm>
+          <a:off x="0" y="0"/>
+          <a:ext cx="0" cy="0"/>
+          <a:chOff x="0" y="0"/>
+          <a:chExt cx="0" cy="0"/>
+        </a:xfrm>
+      </p:grpSpPr>
+      <p:sp>
+        <p:nvSpPr>
+          <p:cNvPr id="2" name="Slide Image Placeholder 1"/>
+          <p:cNvSpPr>
+            <a:spLocks noGrp="1" noRot="1" noChangeAspect="1"/>
+          </p:cNvSpPr>
+          <p:nvPr>
+            <p:ph type="sldImg"/>
+          </p:nvPr>
+        </p:nvSpPr>
+        <p:spPr/>
+      </p:sp>
+      <p:sp>
+        <p:nvSpPr>
+          <p:cNvPr id="3" name="Notes Placeholder 2"/>
+          <p:cNvSpPr>
+            <a:spLocks noGrp="1"/>
+          </p:cNvSpPr>
+          <p:nvPr>
+            <p:ph type="body" idx="1"/>
+          </p:nvPr>
+        </p:nvSpPr>
+        <p:spPr/>
+        <p:txBody>
+          <a:bodyPr/>
+          <a:lstStyle/>
+          <a:p>
+            <a:r>
+              <a:rPr lang="en-US" dirty="0"/>
+              <a:t>Stack technologiczny. TypeScript od bazy po interfejs — te same typy i narzędzia w trzech pakietach monorepo. Wybory podyktowane skalą: PostgreSQL zamiast plików, bo MVCC daje równoczesny zapis bez blokad; NestJS, bo moduły odwzorowują epiki z backlogu; Prisma po typy generowane ze schematu. Silnik wyliczeń w packages/core nie ma ani jednej zależności produkcyjnej. Świadomie pominięto WebSockety, Redis, mikroserwisy i integracje zewnętrzne — każde z nich da się dołożyć bez przebudowy, gdy pojawi się realna potrzeba.</a:t>
+            </a:r>
+            <a:endParaRPr lang="en-US" dirty="0"/>
+          </a:p>
+        </p:txBody>
+      </p:sp>
+      <p:sp>
+        <p:nvSpPr>
+          <p:cNvPr id="4" name="Slide Number Placeholder 3"/>
+          <p:cNvSpPr>
+            <a:spLocks noGrp="1"/>
+          </p:cNvSpPr>
+          <p:nvPr>
+            <p:ph type="sldNum" sz="quarter" idx="10"/>
+          </p:nvPr>
+        </p:nvSpPr>
+        <p:spPr/>
+        <p:txBody>
+          <a:bodyPr/>
+          <a:lstStyle/>
+          <a:p>
+            <a:fld id="{F7021451-1387-4CA6-816F-3879F97B5CBC}" type="slidenum">
+              <a:rPr lang="en-US"/>
+              <a:t>2</a:t>
             </a:fld>
             <a:endParaRPr lang="en-US"/>
           </a:p>
@@ -3353,6 +3442,2392 @@
 </p:sld>
 </file>
 
+<file path=ppt/slides/slide2.xml><?xml version="1.0" encoding="utf-8"?>
+<p:sld xmlns:a="http://schemas.openxmlformats.org/drawingml/2006/main" xmlns:r="http://schemas.openxmlformats.org/officeDocument/2006/relationships" xmlns:p="http://schemas.openxmlformats.org/presentationml/2006/main">
+  <p:cSld name="Slide 2">
+    <p:bg>
+      <p:bgPr>
+        <a:solidFill>
+          <a:srgbClr val="FFFFFF"/>
+        </a:solidFill>
+      </p:bgPr>
+    </p:bg>
+    <p:spTree>
+      <p:nvGrpSpPr>
+        <p:cNvPr id="1" name=""/>
+        <p:cNvGrpSpPr/>
+        <p:nvPr/>
+      </p:nvGrpSpPr>
+      <p:grpSpPr>
+        <a:xfrm>
+          <a:off x="0" y="0"/>
+          <a:ext cx="0" cy="0"/>
+          <a:chOff x="0" y="0"/>
+          <a:chExt cx="0" cy="0"/>
+        </a:xfrm>
+      </p:grpSpPr>
+      <p:sp>
+        <p:nvSpPr>
+          <p:cNvPr id="2" name="Text 0"/>
+          <p:cNvSpPr/>
+          <p:nvPr/>
+        </p:nvSpPr>
+        <p:spPr>
+          <a:xfrm>
+            <a:off x="548640" y="384048"/>
+            <a:ext cx="8595360" cy="457200"/>
+          </a:xfrm>
+          <a:prstGeom prst="rect">
+            <a:avLst/>
+          </a:prstGeom>
+          <a:noFill/>
+          <a:ln/>
+        </p:spPr>
+        <p:txBody>
+          <a:bodyPr wrap="square" lIns="0" tIns="0" rIns="0" bIns="0" rtlCol="0" anchor="ctr"/>
+          <a:lstStyle/>
+          <a:p>
+            <a:pPr indent="0" marL="0">
+              <a:buNone/>
+            </a:pPr>
+            <a:r>
+              <a:rPr lang="en-US" sz="2900" b="1" dirty="0">
+                <a:solidFill>
+                  <a:srgbClr val="0A2E24"/>
+                </a:solidFill>
+                <a:latin typeface="Cambria" pitchFamily="34" charset="0"/>
+                <a:ea typeface="Cambria" pitchFamily="34" charset="-122"/>
+                <a:cs typeface="Cambria" pitchFamily="34" charset="-120"/>
+              </a:rPr>
+              <a:t>Stack technologiczny</a:t>
+            </a:r>
+            <a:endParaRPr lang="en-US" sz="2900" dirty="0"/>
+          </a:p>
+        </p:txBody>
+      </p:sp>
+      <p:sp>
+        <p:nvSpPr>
+          <p:cNvPr id="3" name="Text 1"/>
+          <p:cNvSpPr/>
+          <p:nvPr/>
+        </p:nvSpPr>
+        <p:spPr>
+          <a:xfrm>
+            <a:off x="548640" y="859536"/>
+            <a:ext cx="8595360" cy="274320"/>
+          </a:xfrm>
+          <a:prstGeom prst="rect">
+            <a:avLst/>
+          </a:prstGeom>
+          <a:noFill/>
+          <a:ln/>
+        </p:spPr>
+        <p:txBody>
+          <a:bodyPr wrap="square" lIns="0" tIns="0" rIns="0" bIns="0" rtlCol="0" anchor="ctr"/>
+          <a:lstStyle/>
+          <a:p>
+            <a:pPr indent="0" marL="0">
+              <a:buNone/>
+            </a:pPr>
+            <a:r>
+              <a:rPr lang="en-US" sz="1200" dirty="0">
+                <a:solidFill>
+                  <a:srgbClr val="5F7268"/>
+                </a:solidFill>
+                <a:latin typeface="Calibri" pitchFamily="34" charset="0"/>
+                <a:ea typeface="Calibri" pitchFamily="34" charset="-122"/>
+                <a:cs typeface="Calibri" pitchFamily="34" charset="-120"/>
+              </a:rPr>
+              <a:t>Jeden język od bazy po interfejs · każda zależność dobrana pod konkretną potrzebę</a:t>
+            </a:r>
+            <a:endParaRPr lang="en-US" sz="1200" dirty="0"/>
+          </a:p>
+        </p:txBody>
+      </p:sp>
+      <p:sp>
+        <p:nvSpPr>
+          <p:cNvPr id="4" name="Shape 2"/>
+          <p:cNvSpPr/>
+          <p:nvPr/>
+        </p:nvSpPr>
+        <p:spPr>
+          <a:xfrm>
+            <a:off x="548640" y="1225296"/>
+            <a:ext cx="3514344" cy="1737360"/>
+          </a:xfrm>
+          <a:prstGeom prst="roundRect">
+            <a:avLst>
+              <a:gd name="adj" fmla="val 2632"/>
+            </a:avLst>
+          </a:prstGeom>
+          <a:solidFill>
+            <a:srgbClr val="F3F7F5"/>
+          </a:solidFill>
+          <a:ln w="12700">
+            <a:solidFill>
+              <a:srgbClr val="DEE8E3"/>
+            </a:solidFill>
+            <a:prstDash val="solid"/>
+          </a:ln>
+          <a:effectLst>
+            <a:outerShdw sx="100000" sy="100000" kx="0" ky="0" algn="bl" rotWithShape="0" blurRad="76200" dist="12700" dir="5400000">
+              <a:srgbClr val="BFCFC8">
+                <a:alpha val="45000"/>
+              </a:srgbClr>
+            </a:outerShdw>
+          </a:effectLst>
+        </p:spPr>
+      </p:sp>
+      <p:sp>
+        <p:nvSpPr>
+          <p:cNvPr id="5" name="Shape 3"/>
+          <p:cNvSpPr/>
+          <p:nvPr/>
+        </p:nvSpPr>
+        <p:spPr>
+          <a:xfrm>
+            <a:off x="694944" y="1371600"/>
+            <a:ext cx="603504" cy="246888"/>
+          </a:xfrm>
+          <a:prstGeom prst="roundRect">
+            <a:avLst>
+              <a:gd name="adj" fmla="val 22222"/>
+            </a:avLst>
+          </a:prstGeom>
+          <a:solidFill>
+            <a:srgbClr val="007A53"/>
+          </a:solidFill>
+          <a:ln w="12700">
+            <a:solidFill>
+              <a:srgbClr val="007A53"/>
+            </a:solidFill>
+            <a:prstDash val="solid"/>
+          </a:ln>
+        </p:spPr>
+      </p:sp>
+      <p:sp>
+        <p:nvSpPr>
+          <p:cNvPr id="6" name="Text 4"/>
+          <p:cNvSpPr/>
+          <p:nvPr/>
+        </p:nvSpPr>
+        <p:spPr>
+          <a:xfrm>
+            <a:off x="694944" y="1371600"/>
+            <a:ext cx="603504" cy="246888"/>
+          </a:xfrm>
+          <a:prstGeom prst="rect">
+            <a:avLst/>
+          </a:prstGeom>
+          <a:noFill/>
+          <a:ln/>
+        </p:spPr>
+        <p:txBody>
+          <a:bodyPr wrap="square" lIns="0" tIns="0" rIns="0" bIns="0" rtlCol="0" anchor="ctr"/>
+          <a:lstStyle/>
+          <a:p>
+            <a:pPr algn="ctr" indent="0" marL="0">
+              <a:buNone/>
+            </a:pPr>
+            <a:r>
+              <a:rPr lang="en-US" sz="900" b="1" dirty="0">
+                <a:solidFill>
+                  <a:srgbClr val="FFFFFF"/>
+                </a:solidFill>
+                <a:latin typeface="Calibri" pitchFamily="34" charset="0"/>
+                <a:ea typeface="Calibri" pitchFamily="34" charset="-122"/>
+                <a:cs typeface="Calibri" pitchFamily="34" charset="-120"/>
+              </a:rPr>
+              <a:t>BAZA</a:t>
+            </a:r>
+            <a:endParaRPr lang="en-US" sz="900" dirty="0"/>
+          </a:p>
+        </p:txBody>
+      </p:sp>
+      <p:sp>
+        <p:nvSpPr>
+          <p:cNvPr id="7" name="Text 5"/>
+          <p:cNvSpPr/>
+          <p:nvPr/>
+        </p:nvSpPr>
+        <p:spPr>
+          <a:xfrm>
+            <a:off x="1408176" y="1353312"/>
+            <a:ext cx="2508504" cy="256032"/>
+          </a:xfrm>
+          <a:prstGeom prst="rect">
+            <a:avLst/>
+          </a:prstGeom>
+          <a:noFill/>
+          <a:ln/>
+        </p:spPr>
+        <p:txBody>
+          <a:bodyPr wrap="square" lIns="0" tIns="0" rIns="0" bIns="0" rtlCol="0" anchor="ctr"/>
+          <a:lstStyle/>
+          <a:p>
+            <a:pPr indent="0" marL="0">
+              <a:buNone/>
+            </a:pPr>
+            <a:r>
+              <a:rPr lang="en-US" sz="1300" b="1" dirty="0">
+                <a:solidFill>
+                  <a:srgbClr val="0A2E24"/>
+                </a:solidFill>
+                <a:latin typeface="Calibri" pitchFamily="34" charset="0"/>
+                <a:ea typeface="Calibri" pitchFamily="34" charset="-122"/>
+                <a:cs typeface="Calibri" pitchFamily="34" charset="-120"/>
+              </a:rPr>
+              <a:t>Język i narzędzia</a:t>
+            </a:r>
+            <a:endParaRPr lang="en-US" sz="1300" dirty="0"/>
+          </a:p>
+        </p:txBody>
+      </p:sp>
+      <p:sp>
+        <p:nvSpPr>
+          <p:cNvPr id="8" name="Text 6"/>
+          <p:cNvSpPr/>
+          <p:nvPr/>
+        </p:nvSpPr>
+        <p:spPr>
+          <a:xfrm>
+            <a:off x="694944" y="1719072"/>
+            <a:ext cx="3221736" cy="1115568"/>
+          </a:xfrm>
+          <a:prstGeom prst="rect">
+            <a:avLst/>
+          </a:prstGeom>
+          <a:noFill/>
+          <a:ln/>
+        </p:spPr>
+        <p:txBody>
+          <a:bodyPr wrap="square" lIns="0" tIns="0" rIns="0" bIns="0" rtlCol="0" anchor="ctr"/>
+          <a:lstStyle/>
+          <a:p>
+            <a:pPr indent="0" marL="0">
+              <a:lnSpc>
+                <a:spcPct val="112000"/>
+              </a:lnSpc>
+              <a:buNone/>
+            </a:pPr>
+            <a:r>
+              <a:rPr lang="en-US" sz="1050" b="1" dirty="0">
+                <a:solidFill>
+                  <a:srgbClr val="16241E"/>
+                </a:solidFill>
+                <a:latin typeface="Calibri" pitchFamily="34" charset="0"/>
+                <a:ea typeface="Calibri" pitchFamily="34" charset="-122"/>
+                <a:cs typeface="Calibri" pitchFamily="34" charset="-120"/>
+              </a:rPr>
+              <a:t>TypeScript 5.6</a:t>
+            </a:r>
+            <a:pPr indent="0" marL="0">
+              <a:lnSpc>
+                <a:spcPct val="112000"/>
+              </a:lnSpc>
+              <a:buNone/>
+            </a:pPr>
+            <a:r>
+              <a:rPr lang="en-US" sz="1050" dirty="0">
+                <a:solidFill>
+                  <a:srgbClr val="5F7268"/>
+                </a:solidFill>
+                <a:latin typeface="Calibri" pitchFamily="34" charset="0"/>
+                <a:ea typeface="Calibri" pitchFamily="34" charset="-122"/>
+                <a:cs typeface="Calibri" pitchFamily="34" charset="-120"/>
+              </a:rPr>
+              <a:t>  front, backend i silnik w jednym języku</a:t>
+            </a:r>
+            <a:endParaRPr lang="en-US" sz="1050" dirty="0"/>
+          </a:p>
+          <a:p>
+            <a:pPr indent="0" marL="0">
+              <a:lnSpc>
+                <a:spcPct val="112000"/>
+              </a:lnSpc>
+              <a:buNone/>
+            </a:pPr>
+            <a:r>
+              <a:rPr lang="en-US" sz="1050" b="1" dirty="0">
+                <a:solidFill>
+                  <a:srgbClr val="16241E"/>
+                </a:solidFill>
+                <a:latin typeface="Calibri" pitchFamily="34" charset="0"/>
+                <a:ea typeface="Calibri" pitchFamily="34" charset="-122"/>
+                <a:cs typeface="Calibri" pitchFamily="34" charset="-120"/>
+              </a:rPr>
+              <a:t>Node 22 · pnpm 10</a:t>
+            </a:r>
+            <a:pPr indent="0" marL="0">
+              <a:lnSpc>
+                <a:spcPct val="112000"/>
+              </a:lnSpc>
+              <a:buNone/>
+            </a:pPr>
+            <a:r>
+              <a:rPr lang="en-US" sz="1050" dirty="0">
+                <a:solidFill>
+                  <a:srgbClr val="5F7268"/>
+                </a:solidFill>
+                <a:latin typeface="Calibri" pitchFamily="34" charset="0"/>
+                <a:ea typeface="Calibri" pitchFamily="34" charset="-122"/>
+                <a:cs typeface="Calibri" pitchFamily="34" charset="-120"/>
+              </a:rPr>
+              <a:t>  monorepo na workspaces</a:t>
+            </a:r>
+            <a:endParaRPr lang="en-US" sz="1050" dirty="0"/>
+          </a:p>
+          <a:p>
+            <a:pPr indent="0" marL="0">
+              <a:lnSpc>
+                <a:spcPct val="112000"/>
+              </a:lnSpc>
+              <a:buNone/>
+            </a:pPr>
+            <a:r>
+              <a:rPr lang="en-US" sz="1050" b="1" dirty="0">
+                <a:solidFill>
+                  <a:srgbClr val="16241E"/>
+                </a:solidFill>
+                <a:latin typeface="Calibri" pitchFamily="34" charset="0"/>
+                <a:ea typeface="Calibri" pitchFamily="34" charset="-122"/>
+                <a:cs typeface="Calibri" pitchFamily="34" charset="-120"/>
+              </a:rPr>
+              <a:t>Vitest 2</a:t>
+            </a:r>
+            <a:pPr indent="0" marL="0">
+              <a:lnSpc>
+                <a:spcPct val="112000"/>
+              </a:lnSpc>
+              <a:buNone/>
+            </a:pPr>
+            <a:r>
+              <a:rPr lang="en-US" sz="1050" dirty="0">
+                <a:solidFill>
+                  <a:srgbClr val="5F7268"/>
+                </a:solidFill>
+                <a:latin typeface="Calibri" pitchFamily="34" charset="0"/>
+                <a:ea typeface="Calibri" pitchFamily="34" charset="-122"/>
+                <a:cs typeface="Calibri" pitchFamily="34" charset="-120"/>
+              </a:rPr>
+              <a:t>  27 testów silnika wyliczeń</a:t>
+            </a:r>
+            <a:endParaRPr lang="en-US" sz="1050" dirty="0"/>
+          </a:p>
+          <a:p>
+            <a:pPr indent="0" marL="0">
+              <a:lnSpc>
+                <a:spcPct val="112000"/>
+              </a:lnSpc>
+              <a:buNone/>
+            </a:pPr>
+            <a:r>
+              <a:rPr lang="en-US" sz="1050" b="1" dirty="0">
+                <a:solidFill>
+                  <a:srgbClr val="16241E"/>
+                </a:solidFill>
+                <a:latin typeface="Calibri" pitchFamily="34" charset="0"/>
+                <a:ea typeface="Calibri" pitchFamily="34" charset="-122"/>
+                <a:cs typeface="Calibri" pitchFamily="34" charset="-120"/>
+              </a:rPr>
+              <a:t>ESLint + jsx-a11y</a:t>
+            </a:r>
+            <a:pPr indent="0" marL="0">
+              <a:lnSpc>
+                <a:spcPct val="112000"/>
+              </a:lnSpc>
+              <a:buNone/>
+            </a:pPr>
+            <a:r>
+              <a:rPr lang="en-US" sz="1050" dirty="0">
+                <a:solidFill>
+                  <a:srgbClr val="5F7268"/>
+                </a:solidFill>
+                <a:latin typeface="Calibri" pitchFamily="34" charset="0"/>
+                <a:ea typeface="Calibri" pitchFamily="34" charset="-122"/>
+                <a:cs typeface="Calibri" pitchFamily="34" charset="-120"/>
+              </a:rPr>
+              <a:t>  reguły także dla dostępności</a:t>
+            </a:r>
+            <a:endParaRPr lang="en-US" sz="1050" dirty="0"/>
+          </a:p>
+          <a:p>
+            <a:pPr indent="0" marL="0">
+              <a:lnSpc>
+                <a:spcPct val="112000"/>
+              </a:lnSpc>
+              <a:buNone/>
+            </a:pPr>
+            <a:r>
+              <a:rPr lang="en-US" sz="1050" b="1" dirty="0">
+                <a:solidFill>
+                  <a:srgbClr val="16241E"/>
+                </a:solidFill>
+                <a:latin typeface="Calibri" pitchFamily="34" charset="0"/>
+                <a:ea typeface="Calibri" pitchFamily="34" charset="-122"/>
+                <a:cs typeface="Calibri" pitchFamily="34" charset="-120"/>
+              </a:rPr>
+              <a:t>Zero `any`</a:t>
+            </a:r>
+            <a:pPr indent="0" marL="0">
+              <a:lnSpc>
+                <a:spcPct val="112000"/>
+              </a:lnSpc>
+              <a:buNone/>
+            </a:pPr>
+            <a:r>
+              <a:rPr lang="en-US" sz="1050" dirty="0">
+                <a:solidFill>
+                  <a:srgbClr val="5F7268"/>
+                </a:solidFill>
+                <a:latin typeface="Calibri" pitchFamily="34" charset="0"/>
+                <a:ea typeface="Calibri" pitchFamily="34" charset="-122"/>
+                <a:cs typeface="Calibri" pitchFamily="34" charset="-120"/>
+              </a:rPr>
+              <a:t>  pełne typowanie w trzech pakietach</a:t>
+            </a:r>
+            <a:endParaRPr lang="en-US" sz="1050" dirty="0"/>
+          </a:p>
+        </p:txBody>
+      </p:sp>
+      <p:sp>
+        <p:nvSpPr>
+          <p:cNvPr id="9" name="Shape 7"/>
+          <p:cNvSpPr/>
+          <p:nvPr/>
+        </p:nvSpPr>
+        <p:spPr>
+          <a:xfrm>
+            <a:off x="4337304" y="1225296"/>
+            <a:ext cx="3514344" cy="1737360"/>
+          </a:xfrm>
+          <a:prstGeom prst="roundRect">
+            <a:avLst>
+              <a:gd name="adj" fmla="val 2632"/>
+            </a:avLst>
+          </a:prstGeom>
+          <a:solidFill>
+            <a:srgbClr val="F3F7F5"/>
+          </a:solidFill>
+          <a:ln w="12700">
+            <a:solidFill>
+              <a:srgbClr val="DEE8E3"/>
+            </a:solidFill>
+            <a:prstDash val="solid"/>
+          </a:ln>
+          <a:effectLst>
+            <a:outerShdw sx="100000" sy="100000" kx="0" ky="0" algn="bl" rotWithShape="0" blurRad="76200" dist="12700" dir="5400000">
+              <a:srgbClr val="BFCFC8">
+                <a:alpha val="45000"/>
+              </a:srgbClr>
+            </a:outerShdw>
+          </a:effectLst>
+        </p:spPr>
+      </p:sp>
+      <p:sp>
+        <p:nvSpPr>
+          <p:cNvPr id="10" name="Shape 8"/>
+          <p:cNvSpPr/>
+          <p:nvPr/>
+        </p:nvSpPr>
+        <p:spPr>
+          <a:xfrm>
+            <a:off x="4483608" y="1371600"/>
+            <a:ext cx="603504" cy="246888"/>
+          </a:xfrm>
+          <a:prstGeom prst="roundRect">
+            <a:avLst>
+              <a:gd name="adj" fmla="val 22222"/>
+            </a:avLst>
+          </a:prstGeom>
+          <a:solidFill>
+            <a:srgbClr val="007A53"/>
+          </a:solidFill>
+          <a:ln w="12700">
+            <a:solidFill>
+              <a:srgbClr val="007A53"/>
+            </a:solidFill>
+            <a:prstDash val="solid"/>
+          </a:ln>
+        </p:spPr>
+      </p:sp>
+      <p:sp>
+        <p:nvSpPr>
+          <p:cNvPr id="11" name="Text 9"/>
+          <p:cNvSpPr/>
+          <p:nvPr/>
+        </p:nvSpPr>
+        <p:spPr>
+          <a:xfrm>
+            <a:off x="4483608" y="1371600"/>
+            <a:ext cx="603504" cy="246888"/>
+          </a:xfrm>
+          <a:prstGeom prst="rect">
+            <a:avLst/>
+          </a:prstGeom>
+          <a:noFill/>
+          <a:ln/>
+        </p:spPr>
+        <p:txBody>
+          <a:bodyPr wrap="square" lIns="0" tIns="0" rIns="0" bIns="0" rtlCol="0" anchor="ctr"/>
+          <a:lstStyle/>
+          <a:p>
+            <a:pPr algn="ctr" indent="0" marL="0">
+              <a:buNone/>
+            </a:pPr>
+            <a:r>
+              <a:rPr lang="en-US" sz="900" b="1" dirty="0">
+                <a:solidFill>
+                  <a:srgbClr val="FFFFFF"/>
+                </a:solidFill>
+                <a:latin typeface="Calibri" pitchFamily="34" charset="0"/>
+                <a:ea typeface="Calibri" pitchFamily="34" charset="-122"/>
+                <a:cs typeface="Calibri" pitchFamily="34" charset="-120"/>
+              </a:rPr>
+              <a:t>WEB</a:t>
+            </a:r>
+            <a:endParaRPr lang="en-US" sz="900" dirty="0"/>
+          </a:p>
+        </p:txBody>
+      </p:sp>
+      <p:sp>
+        <p:nvSpPr>
+          <p:cNvPr id="12" name="Text 10"/>
+          <p:cNvSpPr/>
+          <p:nvPr/>
+        </p:nvSpPr>
+        <p:spPr>
+          <a:xfrm>
+            <a:off x="5196840" y="1353312"/>
+            <a:ext cx="2508504" cy="256032"/>
+          </a:xfrm>
+          <a:prstGeom prst="rect">
+            <a:avLst/>
+          </a:prstGeom>
+          <a:noFill/>
+          <a:ln/>
+        </p:spPr>
+        <p:txBody>
+          <a:bodyPr wrap="square" lIns="0" tIns="0" rIns="0" bIns="0" rtlCol="0" anchor="ctr"/>
+          <a:lstStyle/>
+          <a:p>
+            <a:pPr indent="0" marL="0">
+              <a:buNone/>
+            </a:pPr>
+            <a:r>
+              <a:rPr lang="en-US" sz="1300" b="1" dirty="0">
+                <a:solidFill>
+                  <a:srgbClr val="0A2E24"/>
+                </a:solidFill>
+                <a:latin typeface="Calibri" pitchFamily="34" charset="0"/>
+                <a:ea typeface="Calibri" pitchFamily="34" charset="-122"/>
+                <a:cs typeface="Calibri" pitchFamily="34" charset="-120"/>
+              </a:rPr>
+              <a:t>Frontend</a:t>
+            </a:r>
+            <a:endParaRPr lang="en-US" sz="1300" dirty="0"/>
+          </a:p>
+        </p:txBody>
+      </p:sp>
+      <p:sp>
+        <p:nvSpPr>
+          <p:cNvPr id="13" name="Text 11"/>
+          <p:cNvSpPr/>
+          <p:nvPr/>
+        </p:nvSpPr>
+        <p:spPr>
+          <a:xfrm>
+            <a:off x="4483608" y="1719072"/>
+            <a:ext cx="3221736" cy="1115568"/>
+          </a:xfrm>
+          <a:prstGeom prst="rect">
+            <a:avLst/>
+          </a:prstGeom>
+          <a:noFill/>
+          <a:ln/>
+        </p:spPr>
+        <p:txBody>
+          <a:bodyPr wrap="square" lIns="0" tIns="0" rIns="0" bIns="0" rtlCol="0" anchor="ctr"/>
+          <a:lstStyle/>
+          <a:p>
+            <a:pPr indent="0" marL="0">
+              <a:lnSpc>
+                <a:spcPct val="112000"/>
+              </a:lnSpc>
+              <a:buNone/>
+            </a:pPr>
+            <a:r>
+              <a:rPr lang="en-US" sz="1050" b="1" dirty="0">
+                <a:solidFill>
+                  <a:srgbClr val="16241E"/>
+                </a:solidFill>
+                <a:latin typeface="Calibri" pitchFamily="34" charset="0"/>
+                <a:ea typeface="Calibri" pitchFamily="34" charset="-122"/>
+                <a:cs typeface="Calibri" pitchFamily="34" charset="-120"/>
+              </a:rPr>
+              <a:t>React 18 + Vite 6</a:t>
+            </a:r>
+            <a:pPr indent="0" marL="0">
+              <a:lnSpc>
+                <a:spcPct val="112000"/>
+              </a:lnSpc>
+              <a:buNone/>
+            </a:pPr>
+            <a:r>
+              <a:rPr lang="en-US" sz="1050" dirty="0">
+                <a:solidFill>
+                  <a:srgbClr val="5F7268"/>
+                </a:solidFill>
+                <a:latin typeface="Calibri" pitchFamily="34" charset="0"/>
+                <a:ea typeface="Calibri" pitchFamily="34" charset="-122"/>
+                <a:cs typeface="Calibri" pitchFamily="34" charset="-120"/>
+              </a:rPr>
+              <a:t>  szybki dev server, build statyczny</a:t>
+            </a:r>
+            <a:endParaRPr lang="en-US" sz="1050" dirty="0"/>
+          </a:p>
+          <a:p>
+            <a:pPr indent="0" marL="0">
+              <a:lnSpc>
+                <a:spcPct val="112000"/>
+              </a:lnSpc>
+              <a:buNone/>
+            </a:pPr>
+            <a:r>
+              <a:rPr lang="en-US" sz="1050" b="1" dirty="0">
+                <a:solidFill>
+                  <a:srgbClr val="16241E"/>
+                </a:solidFill>
+                <a:latin typeface="Calibri" pitchFamily="34" charset="0"/>
+                <a:ea typeface="Calibri" pitchFamily="34" charset="-122"/>
+                <a:cs typeface="Calibri" pitchFamily="34" charset="-120"/>
+              </a:rPr>
+              <a:t>react-router 6</a:t>
+            </a:r>
+            <a:pPr indent="0" marL="0">
+              <a:lnSpc>
+                <a:spcPct val="112000"/>
+              </a:lnSpc>
+              <a:buNone/>
+            </a:pPr>
+            <a:r>
+              <a:rPr lang="en-US" sz="1050" dirty="0">
+                <a:solidFill>
+                  <a:srgbClr val="5F7268"/>
+                </a:solidFill>
+                <a:latin typeface="Calibri" pitchFamily="34" charset="0"/>
+                <a:ea typeface="Calibri" pitchFamily="34" charset="-122"/>
+                <a:cs typeface="Calibri" pitchFamily="34" charset="-120"/>
+              </a:rPr>
+              <a:t>  trasy generowane z uprawnień roli</a:t>
+            </a:r>
+            <a:endParaRPr lang="en-US" sz="1050" dirty="0"/>
+          </a:p>
+          <a:p>
+            <a:pPr indent="0" marL="0">
+              <a:lnSpc>
+                <a:spcPct val="112000"/>
+              </a:lnSpc>
+              <a:buNone/>
+            </a:pPr>
+            <a:r>
+              <a:rPr lang="en-US" sz="1050" b="1" dirty="0">
+                <a:solidFill>
+                  <a:srgbClr val="16241E"/>
+                </a:solidFill>
+                <a:latin typeface="Calibri" pitchFamily="34" charset="0"/>
+                <a:ea typeface="Calibri" pitchFamily="34" charset="-122"/>
+                <a:cs typeface="Calibri" pitchFamily="34" charset="-120"/>
+              </a:rPr>
+              <a:t>lucide-react</a:t>
+            </a:r>
+            <a:pPr indent="0" marL="0">
+              <a:lnSpc>
+                <a:spcPct val="112000"/>
+              </a:lnSpc>
+              <a:buNone/>
+            </a:pPr>
+            <a:r>
+              <a:rPr lang="en-US" sz="1050" dirty="0">
+                <a:solidFill>
+                  <a:srgbClr val="5F7268"/>
+                </a:solidFill>
+                <a:latin typeface="Calibri" pitchFamily="34" charset="0"/>
+                <a:ea typeface="Calibri" pitchFamily="34" charset="-122"/>
+                <a:cs typeface="Calibri" pitchFamily="34" charset="-120"/>
+              </a:rPr>
+              <a:t>  ikony spójne z prototypem</a:t>
+            </a:r>
+            <a:endParaRPr lang="en-US" sz="1050" dirty="0"/>
+          </a:p>
+          <a:p>
+            <a:pPr indent="0" marL="0">
+              <a:lnSpc>
+                <a:spcPct val="112000"/>
+              </a:lnSpc>
+              <a:buNone/>
+            </a:pPr>
+            <a:r>
+              <a:rPr lang="en-US" sz="1050" b="1" dirty="0">
+                <a:solidFill>
+                  <a:srgbClr val="16241E"/>
+                </a:solidFill>
+                <a:latin typeface="Calibri" pitchFamily="34" charset="0"/>
+                <a:ea typeface="Calibri" pitchFamily="34" charset="-122"/>
+                <a:cs typeface="Calibri" pitchFamily="34" charset="-120"/>
+              </a:rPr>
+              <a:t>Bez biblioteki stanu</a:t>
+            </a:r>
+            <a:pPr indent="0" marL="0">
+              <a:lnSpc>
+                <a:spcPct val="112000"/>
+              </a:lnSpc>
+              <a:buNone/>
+            </a:pPr>
+            <a:r>
+              <a:rPr lang="en-US" sz="1050" dirty="0">
+                <a:solidFill>
+                  <a:srgbClr val="5F7268"/>
+                </a:solidFill>
+                <a:latin typeface="Calibri" pitchFamily="34" charset="0"/>
+                <a:ea typeface="Calibri" pitchFamily="34" charset="-122"/>
+                <a:cs typeface="Calibri" pitchFamily="34" charset="-120"/>
+              </a:rPr>
+              <a:t>  fetch + stan komponentu wystarcza</a:t>
+            </a:r>
+            <a:endParaRPr lang="en-US" sz="1050" dirty="0"/>
+          </a:p>
+          <a:p>
+            <a:pPr indent="0" marL="0">
+              <a:lnSpc>
+                <a:spcPct val="112000"/>
+              </a:lnSpc>
+              <a:buNone/>
+            </a:pPr>
+            <a:r>
+              <a:rPr lang="en-US" sz="1050" b="1" dirty="0">
+                <a:solidFill>
+                  <a:srgbClr val="16241E"/>
+                </a:solidFill>
+                <a:latin typeface="Calibri" pitchFamily="34" charset="0"/>
+                <a:ea typeface="Calibri" pitchFamily="34" charset="-122"/>
+                <a:cs typeface="Calibri" pitchFamily="34" charset="-120"/>
+              </a:rPr>
+              <a:t>Tryb jasny i ciemny</a:t>
+            </a:r>
+            <a:pPr indent="0" marL="0">
+              <a:lnSpc>
+                <a:spcPct val="112000"/>
+              </a:lnSpc>
+              <a:buNone/>
+            </a:pPr>
+            <a:r>
+              <a:rPr lang="en-US" sz="1050" dirty="0">
+                <a:solidFill>
+                  <a:srgbClr val="5F7268"/>
+                </a:solidFill>
+                <a:latin typeface="Calibri" pitchFamily="34" charset="0"/>
+                <a:ea typeface="Calibri" pitchFamily="34" charset="-122"/>
+                <a:cs typeface="Calibri" pitchFamily="34" charset="-120"/>
+              </a:rPr>
+              <a:t>  motyw przełączany w topbarze</a:t>
+            </a:r>
+            <a:endParaRPr lang="en-US" sz="1050" dirty="0"/>
+          </a:p>
+        </p:txBody>
+      </p:sp>
+      <p:sp>
+        <p:nvSpPr>
+          <p:cNvPr id="14" name="Shape 12"/>
+          <p:cNvSpPr/>
+          <p:nvPr/>
+        </p:nvSpPr>
+        <p:spPr>
+          <a:xfrm>
+            <a:off x="8125968" y="1225296"/>
+            <a:ext cx="3514344" cy="1737360"/>
+          </a:xfrm>
+          <a:prstGeom prst="roundRect">
+            <a:avLst>
+              <a:gd name="adj" fmla="val 2632"/>
+            </a:avLst>
+          </a:prstGeom>
+          <a:solidFill>
+            <a:srgbClr val="F3F7F5"/>
+          </a:solidFill>
+          <a:ln w="12700">
+            <a:solidFill>
+              <a:srgbClr val="DEE8E3"/>
+            </a:solidFill>
+            <a:prstDash val="solid"/>
+          </a:ln>
+          <a:effectLst>
+            <a:outerShdw sx="100000" sy="100000" kx="0" ky="0" algn="bl" rotWithShape="0" blurRad="76200" dist="12700" dir="5400000">
+              <a:srgbClr val="BFCFC8">
+                <a:alpha val="45000"/>
+              </a:srgbClr>
+            </a:outerShdw>
+          </a:effectLst>
+        </p:spPr>
+      </p:sp>
+      <p:sp>
+        <p:nvSpPr>
+          <p:cNvPr id="15" name="Shape 13"/>
+          <p:cNvSpPr/>
+          <p:nvPr/>
+        </p:nvSpPr>
+        <p:spPr>
+          <a:xfrm>
+            <a:off x="8272272" y="1371600"/>
+            <a:ext cx="603504" cy="246888"/>
+          </a:xfrm>
+          <a:prstGeom prst="roundRect">
+            <a:avLst>
+              <a:gd name="adj" fmla="val 22222"/>
+            </a:avLst>
+          </a:prstGeom>
+          <a:solidFill>
+            <a:srgbClr val="007A53"/>
+          </a:solidFill>
+          <a:ln w="12700">
+            <a:solidFill>
+              <a:srgbClr val="007A53"/>
+            </a:solidFill>
+            <a:prstDash val="solid"/>
+          </a:ln>
+        </p:spPr>
+      </p:sp>
+      <p:sp>
+        <p:nvSpPr>
+          <p:cNvPr id="16" name="Text 14"/>
+          <p:cNvSpPr/>
+          <p:nvPr/>
+        </p:nvSpPr>
+        <p:spPr>
+          <a:xfrm>
+            <a:off x="8272272" y="1371600"/>
+            <a:ext cx="603504" cy="246888"/>
+          </a:xfrm>
+          <a:prstGeom prst="rect">
+            <a:avLst/>
+          </a:prstGeom>
+          <a:noFill/>
+          <a:ln/>
+        </p:spPr>
+        <p:txBody>
+          <a:bodyPr wrap="square" lIns="0" tIns="0" rIns="0" bIns="0" rtlCol="0" anchor="ctr"/>
+          <a:lstStyle/>
+          <a:p>
+            <a:pPr algn="ctr" indent="0" marL="0">
+              <a:buNone/>
+            </a:pPr>
+            <a:r>
+              <a:rPr lang="en-US" sz="900" b="1" dirty="0">
+                <a:solidFill>
+                  <a:srgbClr val="FFFFFF"/>
+                </a:solidFill>
+                <a:latin typeface="Calibri" pitchFamily="34" charset="0"/>
+                <a:ea typeface="Calibri" pitchFamily="34" charset="-122"/>
+                <a:cs typeface="Calibri" pitchFamily="34" charset="-120"/>
+              </a:rPr>
+              <a:t>API</a:t>
+            </a:r>
+            <a:endParaRPr lang="en-US" sz="900" dirty="0"/>
+          </a:p>
+        </p:txBody>
+      </p:sp>
+      <p:sp>
+        <p:nvSpPr>
+          <p:cNvPr id="17" name="Text 15"/>
+          <p:cNvSpPr/>
+          <p:nvPr/>
+        </p:nvSpPr>
+        <p:spPr>
+          <a:xfrm>
+            <a:off x="8985504" y="1353312"/>
+            <a:ext cx="2508504" cy="256032"/>
+          </a:xfrm>
+          <a:prstGeom prst="rect">
+            <a:avLst/>
+          </a:prstGeom>
+          <a:noFill/>
+          <a:ln/>
+        </p:spPr>
+        <p:txBody>
+          <a:bodyPr wrap="square" lIns="0" tIns="0" rIns="0" bIns="0" rtlCol="0" anchor="ctr"/>
+          <a:lstStyle/>
+          <a:p>
+            <a:pPr indent="0" marL="0">
+              <a:buNone/>
+            </a:pPr>
+            <a:r>
+              <a:rPr lang="en-US" sz="1300" b="1" dirty="0">
+                <a:solidFill>
+                  <a:srgbClr val="0A2E24"/>
+                </a:solidFill>
+                <a:latin typeface="Calibri" pitchFamily="34" charset="0"/>
+                <a:ea typeface="Calibri" pitchFamily="34" charset="-122"/>
+                <a:cs typeface="Calibri" pitchFamily="34" charset="-120"/>
+              </a:rPr>
+              <a:t>Backend</a:t>
+            </a:r>
+            <a:endParaRPr lang="en-US" sz="1300" dirty="0"/>
+          </a:p>
+        </p:txBody>
+      </p:sp>
+      <p:sp>
+        <p:nvSpPr>
+          <p:cNvPr id="18" name="Text 16"/>
+          <p:cNvSpPr/>
+          <p:nvPr/>
+        </p:nvSpPr>
+        <p:spPr>
+          <a:xfrm>
+            <a:off x="8272272" y="1719072"/>
+            <a:ext cx="3221736" cy="1115568"/>
+          </a:xfrm>
+          <a:prstGeom prst="rect">
+            <a:avLst/>
+          </a:prstGeom>
+          <a:noFill/>
+          <a:ln/>
+        </p:spPr>
+        <p:txBody>
+          <a:bodyPr wrap="square" lIns="0" tIns="0" rIns="0" bIns="0" rtlCol="0" anchor="ctr"/>
+          <a:lstStyle/>
+          <a:p>
+            <a:pPr indent="0" marL="0">
+              <a:lnSpc>
+                <a:spcPct val="112000"/>
+              </a:lnSpc>
+              <a:buNone/>
+            </a:pPr>
+            <a:r>
+              <a:rPr lang="en-US" sz="1050" b="1" dirty="0">
+                <a:solidFill>
+                  <a:srgbClr val="16241E"/>
+                </a:solidFill>
+                <a:latin typeface="Calibri" pitchFamily="34" charset="0"/>
+                <a:ea typeface="Calibri" pitchFamily="34" charset="-122"/>
+                <a:cs typeface="Calibri" pitchFamily="34" charset="-120"/>
+              </a:rPr>
+              <a:t>NestJS 10</a:t>
+            </a:r>
+            <a:pPr indent="0" marL="0">
+              <a:lnSpc>
+                <a:spcPct val="112000"/>
+              </a:lnSpc>
+              <a:buNone/>
+            </a:pPr>
+            <a:r>
+              <a:rPr lang="en-US" sz="1050" dirty="0">
+                <a:solidFill>
+                  <a:srgbClr val="5F7268"/>
+                </a:solidFill>
+                <a:latin typeface="Calibri" pitchFamily="34" charset="0"/>
+                <a:ea typeface="Calibri" pitchFamily="34" charset="-122"/>
+                <a:cs typeface="Calibri" pitchFamily="34" charset="-120"/>
+              </a:rPr>
+              <a:t>  moduły odwzorowują epiki z backlogu</a:t>
+            </a:r>
+            <a:endParaRPr lang="en-US" sz="1050" dirty="0"/>
+          </a:p>
+          <a:p>
+            <a:pPr indent="0" marL="0">
+              <a:lnSpc>
+                <a:spcPct val="112000"/>
+              </a:lnSpc>
+              <a:buNone/>
+            </a:pPr>
+            <a:r>
+              <a:rPr lang="en-US" sz="1050" b="1" dirty="0">
+                <a:solidFill>
+                  <a:srgbClr val="16241E"/>
+                </a:solidFill>
+                <a:latin typeface="Calibri" pitchFamily="34" charset="0"/>
+                <a:ea typeface="Calibri" pitchFamily="34" charset="-122"/>
+                <a:cs typeface="Calibri" pitchFamily="34" charset="-120"/>
+              </a:rPr>
+              <a:t>class-validator</a:t>
+            </a:r>
+            <a:pPr indent="0" marL="0">
+              <a:lnSpc>
+                <a:spcPct val="112000"/>
+              </a:lnSpc>
+              <a:buNone/>
+            </a:pPr>
+            <a:r>
+              <a:rPr lang="en-US" sz="1050" dirty="0">
+                <a:solidFill>
+                  <a:srgbClr val="5F7268"/>
+                </a:solidFill>
+                <a:latin typeface="Calibri" pitchFamily="34" charset="0"/>
+                <a:ea typeface="Calibri" pitchFamily="34" charset="-122"/>
+                <a:cs typeface="Calibri" pitchFamily="34" charset="-120"/>
+              </a:rPr>
+              <a:t>  walidacja DTO na wejściu</a:t>
+            </a:r>
+            <a:endParaRPr lang="en-US" sz="1050" dirty="0"/>
+          </a:p>
+          <a:p>
+            <a:pPr indent="0" marL="0">
+              <a:lnSpc>
+                <a:spcPct val="112000"/>
+              </a:lnSpc>
+              <a:buNone/>
+            </a:pPr>
+            <a:r>
+              <a:rPr lang="en-US" sz="1050" b="1" dirty="0">
+                <a:solidFill>
+                  <a:srgbClr val="16241E"/>
+                </a:solidFill>
+                <a:latin typeface="Calibri" pitchFamily="34" charset="0"/>
+                <a:ea typeface="Calibri" pitchFamily="34" charset="-122"/>
+                <a:cs typeface="Calibri" pitchFamily="34" charset="-120"/>
+              </a:rPr>
+              <a:t>helmet · throttler</a:t>
+            </a:r>
+            <a:pPr indent="0" marL="0">
+              <a:lnSpc>
+                <a:spcPct val="112000"/>
+              </a:lnSpc>
+              <a:buNone/>
+            </a:pPr>
+            <a:r>
+              <a:rPr lang="en-US" sz="1050" dirty="0">
+                <a:solidFill>
+                  <a:srgbClr val="5F7268"/>
+                </a:solidFill>
+                <a:latin typeface="Calibri" pitchFamily="34" charset="0"/>
+                <a:ea typeface="Calibri" pitchFamily="34" charset="-122"/>
+                <a:cs typeface="Calibri" pitchFamily="34" charset="-120"/>
+              </a:rPr>
+              <a:t>  nagłówki i limit żądań</a:t>
+            </a:r>
+            <a:endParaRPr lang="en-US" sz="1050" dirty="0"/>
+          </a:p>
+          <a:p>
+            <a:pPr indent="0" marL="0">
+              <a:lnSpc>
+                <a:spcPct val="112000"/>
+              </a:lnSpc>
+              <a:buNone/>
+            </a:pPr>
+            <a:r>
+              <a:rPr lang="en-US" sz="1050" b="1" dirty="0">
+                <a:solidFill>
+                  <a:srgbClr val="16241E"/>
+                </a:solidFill>
+                <a:latin typeface="Calibri" pitchFamily="34" charset="0"/>
+                <a:ea typeface="Calibri" pitchFamily="34" charset="-122"/>
+                <a:cs typeface="Calibri" pitchFamily="34" charset="-120"/>
+              </a:rPr>
+              <a:t>jsonwebtoken · scrypt</a:t>
+            </a:r>
+            <a:pPr indent="0" marL="0">
+              <a:lnSpc>
+                <a:spcPct val="112000"/>
+              </a:lnSpc>
+              <a:buNone/>
+            </a:pPr>
+            <a:r>
+              <a:rPr lang="en-US" sz="1050" dirty="0">
+                <a:solidFill>
+                  <a:srgbClr val="5F7268"/>
+                </a:solidFill>
+                <a:latin typeface="Calibri" pitchFamily="34" charset="0"/>
+                <a:ea typeface="Calibri" pitchFamily="34" charset="-122"/>
+                <a:cs typeface="Calibri" pitchFamily="34" charset="-120"/>
+              </a:rPr>
+              <a:t>  sesje i hasła (node:crypto)</a:t>
+            </a:r>
+            <a:endParaRPr lang="en-US" sz="1050" dirty="0"/>
+          </a:p>
+          <a:p>
+            <a:pPr indent="0" marL="0">
+              <a:lnSpc>
+                <a:spcPct val="112000"/>
+              </a:lnSpc>
+              <a:buNone/>
+            </a:pPr>
+            <a:r>
+              <a:rPr lang="en-US" sz="1050" b="1" dirty="0">
+                <a:solidFill>
+                  <a:srgbClr val="16241E"/>
+                </a:solidFill>
+                <a:latin typeface="Calibri" pitchFamily="34" charset="0"/>
+                <a:ea typeface="Calibri" pitchFamily="34" charset="-122"/>
+                <a:cs typeface="Calibri" pitchFamily="34" charset="-120"/>
+              </a:rPr>
+              <a:t>@nestjs/schedule</a:t>
+            </a:r>
+            <a:pPr indent="0" marL="0">
+              <a:lnSpc>
+                <a:spcPct val="112000"/>
+              </a:lnSpc>
+              <a:buNone/>
+            </a:pPr>
+            <a:r>
+              <a:rPr lang="en-US" sz="1050" dirty="0">
+                <a:solidFill>
+                  <a:srgbClr val="5F7268"/>
+                </a:solidFill>
+                <a:latin typeface="Calibri" pitchFamily="34" charset="0"/>
+                <a:ea typeface="Calibri" pitchFamily="34" charset="-122"/>
+                <a:cs typeface="Calibri" pitchFamily="34" charset="-120"/>
+              </a:rPr>
+              <a:t>  cron: przypomnienia, retencja</a:t>
+            </a:r>
+            <a:endParaRPr lang="en-US" sz="1050" dirty="0"/>
+          </a:p>
+        </p:txBody>
+      </p:sp>
+      <p:sp>
+        <p:nvSpPr>
+          <p:cNvPr id="19" name="Shape 17"/>
+          <p:cNvSpPr/>
+          <p:nvPr/>
+        </p:nvSpPr>
+        <p:spPr>
+          <a:xfrm>
+            <a:off x="548640" y="3255264"/>
+            <a:ext cx="3514344" cy="1737360"/>
+          </a:xfrm>
+          <a:prstGeom prst="roundRect">
+            <a:avLst>
+              <a:gd name="adj" fmla="val 2632"/>
+            </a:avLst>
+          </a:prstGeom>
+          <a:solidFill>
+            <a:srgbClr val="F3F7F5"/>
+          </a:solidFill>
+          <a:ln w="12700">
+            <a:solidFill>
+              <a:srgbClr val="DEE8E3"/>
+            </a:solidFill>
+            <a:prstDash val="solid"/>
+          </a:ln>
+          <a:effectLst>
+            <a:outerShdw sx="100000" sy="100000" kx="0" ky="0" algn="bl" rotWithShape="0" blurRad="76200" dist="12700" dir="5400000">
+              <a:srgbClr val="BFCFC8">
+                <a:alpha val="45000"/>
+              </a:srgbClr>
+            </a:outerShdw>
+          </a:effectLst>
+        </p:spPr>
+      </p:sp>
+      <p:sp>
+        <p:nvSpPr>
+          <p:cNvPr id="20" name="Shape 18"/>
+          <p:cNvSpPr/>
+          <p:nvPr/>
+        </p:nvSpPr>
+        <p:spPr>
+          <a:xfrm>
+            <a:off x="694944" y="3401568"/>
+            <a:ext cx="603504" cy="246888"/>
+          </a:xfrm>
+          <a:prstGeom prst="roundRect">
+            <a:avLst>
+              <a:gd name="adj" fmla="val 22222"/>
+            </a:avLst>
+          </a:prstGeom>
+          <a:solidFill>
+            <a:srgbClr val="31708A"/>
+          </a:solidFill>
+          <a:ln w="12700">
+            <a:solidFill>
+              <a:srgbClr val="31708A"/>
+            </a:solidFill>
+            <a:prstDash val="solid"/>
+          </a:ln>
+        </p:spPr>
+      </p:sp>
+      <p:sp>
+        <p:nvSpPr>
+          <p:cNvPr id="21" name="Text 19"/>
+          <p:cNvSpPr/>
+          <p:nvPr/>
+        </p:nvSpPr>
+        <p:spPr>
+          <a:xfrm>
+            <a:off x="694944" y="3401568"/>
+            <a:ext cx="603504" cy="246888"/>
+          </a:xfrm>
+          <a:prstGeom prst="rect">
+            <a:avLst/>
+          </a:prstGeom>
+          <a:noFill/>
+          <a:ln/>
+        </p:spPr>
+        <p:txBody>
+          <a:bodyPr wrap="square" lIns="0" tIns="0" rIns="0" bIns="0" rtlCol="0" anchor="ctr"/>
+          <a:lstStyle/>
+          <a:p>
+            <a:pPr algn="ctr" indent="0" marL="0">
+              <a:buNone/>
+            </a:pPr>
+            <a:r>
+              <a:rPr lang="en-US" sz="900" b="1" dirty="0">
+                <a:solidFill>
+                  <a:srgbClr val="FFFFFF"/>
+                </a:solidFill>
+                <a:latin typeface="Calibri" pitchFamily="34" charset="0"/>
+                <a:ea typeface="Calibri" pitchFamily="34" charset="-122"/>
+                <a:cs typeface="Calibri" pitchFamily="34" charset="-120"/>
+              </a:rPr>
+              <a:t>DB</a:t>
+            </a:r>
+            <a:endParaRPr lang="en-US" sz="900" dirty="0"/>
+          </a:p>
+        </p:txBody>
+      </p:sp>
+      <p:sp>
+        <p:nvSpPr>
+          <p:cNvPr id="22" name="Text 20"/>
+          <p:cNvSpPr/>
+          <p:nvPr/>
+        </p:nvSpPr>
+        <p:spPr>
+          <a:xfrm>
+            <a:off x="1408176" y="3383280"/>
+            <a:ext cx="2508504" cy="256032"/>
+          </a:xfrm>
+          <a:prstGeom prst="rect">
+            <a:avLst/>
+          </a:prstGeom>
+          <a:noFill/>
+          <a:ln/>
+        </p:spPr>
+        <p:txBody>
+          <a:bodyPr wrap="square" lIns="0" tIns="0" rIns="0" bIns="0" rtlCol="0" anchor="ctr"/>
+          <a:lstStyle/>
+          <a:p>
+            <a:pPr indent="0" marL="0">
+              <a:buNone/>
+            </a:pPr>
+            <a:r>
+              <a:rPr lang="en-US" sz="1300" b="1" dirty="0">
+                <a:solidFill>
+                  <a:srgbClr val="0A2E24"/>
+                </a:solidFill>
+                <a:latin typeface="Calibri" pitchFamily="34" charset="0"/>
+                <a:ea typeface="Calibri" pitchFamily="34" charset="-122"/>
+                <a:cs typeface="Calibri" pitchFamily="34" charset="-120"/>
+              </a:rPr>
+              <a:t>Dane</a:t>
+            </a:r>
+            <a:endParaRPr lang="en-US" sz="1300" dirty="0"/>
+          </a:p>
+        </p:txBody>
+      </p:sp>
+      <p:sp>
+        <p:nvSpPr>
+          <p:cNvPr id="23" name="Text 21"/>
+          <p:cNvSpPr/>
+          <p:nvPr/>
+        </p:nvSpPr>
+        <p:spPr>
+          <a:xfrm>
+            <a:off x="694944" y="3749040"/>
+            <a:ext cx="3221736" cy="1115568"/>
+          </a:xfrm>
+          <a:prstGeom prst="rect">
+            <a:avLst/>
+          </a:prstGeom>
+          <a:noFill/>
+          <a:ln/>
+        </p:spPr>
+        <p:txBody>
+          <a:bodyPr wrap="square" lIns="0" tIns="0" rIns="0" bIns="0" rtlCol="0" anchor="ctr"/>
+          <a:lstStyle/>
+          <a:p>
+            <a:pPr indent="0" marL="0">
+              <a:lnSpc>
+                <a:spcPct val="112000"/>
+              </a:lnSpc>
+              <a:buNone/>
+            </a:pPr>
+            <a:r>
+              <a:rPr lang="en-US" sz="1050" b="1" dirty="0">
+                <a:solidFill>
+                  <a:srgbClr val="16241E"/>
+                </a:solidFill>
+                <a:latin typeface="Calibri" pitchFamily="34" charset="0"/>
+                <a:ea typeface="Calibri" pitchFamily="34" charset="-122"/>
+                <a:cs typeface="Calibri" pitchFamily="34" charset="-120"/>
+              </a:rPr>
+              <a:t>PostgreSQL 16</a:t>
+            </a:r>
+            <a:pPr indent="0" marL="0">
+              <a:lnSpc>
+                <a:spcPct val="112000"/>
+              </a:lnSpc>
+              <a:buNone/>
+            </a:pPr>
+            <a:r>
+              <a:rPr lang="en-US" sz="1050" dirty="0">
+                <a:solidFill>
+                  <a:srgbClr val="5F7268"/>
+                </a:solidFill>
+                <a:latin typeface="Calibri" pitchFamily="34" charset="0"/>
+                <a:ea typeface="Calibri" pitchFamily="34" charset="-122"/>
+                <a:cs typeface="Calibri" pitchFamily="34" charset="-120"/>
+              </a:rPr>
+              <a:t>  MVCC — równoczesny zapis bez blokad</a:t>
+            </a:r>
+            <a:endParaRPr lang="en-US" sz="1050" dirty="0"/>
+          </a:p>
+          <a:p>
+            <a:pPr indent="0" marL="0">
+              <a:lnSpc>
+                <a:spcPct val="112000"/>
+              </a:lnSpc>
+              <a:buNone/>
+            </a:pPr>
+            <a:r>
+              <a:rPr lang="en-US" sz="1050" b="1" dirty="0">
+                <a:solidFill>
+                  <a:srgbClr val="16241E"/>
+                </a:solidFill>
+                <a:latin typeface="Calibri" pitchFamily="34" charset="0"/>
+                <a:ea typeface="Calibri" pitchFamily="34" charset="-122"/>
+                <a:cs typeface="Calibri" pitchFamily="34" charset="-120"/>
+              </a:rPr>
+              <a:t>Prisma 6</a:t>
+            </a:r>
+            <a:pPr indent="0" marL="0">
+              <a:lnSpc>
+                <a:spcPct val="112000"/>
+              </a:lnSpc>
+              <a:buNone/>
+            </a:pPr>
+            <a:r>
+              <a:rPr lang="en-US" sz="1050" dirty="0">
+                <a:solidFill>
+                  <a:srgbClr val="5F7268"/>
+                </a:solidFill>
+                <a:latin typeface="Calibri" pitchFamily="34" charset="0"/>
+                <a:ea typeface="Calibri" pitchFamily="34" charset="-122"/>
+                <a:cs typeface="Calibri" pitchFamily="34" charset="-120"/>
+              </a:rPr>
+              <a:t>  schemat, migracje, typy z bazy</a:t>
+            </a:r>
+            <a:endParaRPr lang="en-US" sz="1050" dirty="0"/>
+          </a:p>
+          <a:p>
+            <a:pPr indent="0" marL="0">
+              <a:lnSpc>
+                <a:spcPct val="112000"/>
+              </a:lnSpc>
+              <a:buNone/>
+            </a:pPr>
+            <a:r>
+              <a:rPr lang="en-US" sz="1050" b="1" dirty="0">
+                <a:solidFill>
+                  <a:srgbClr val="16241E"/>
+                </a:solidFill>
+                <a:latin typeface="Calibri" pitchFamily="34" charset="0"/>
+                <a:ea typeface="Calibri" pitchFamily="34" charset="-122"/>
+                <a:cs typeface="Calibri" pitchFamily="34" charset="-120"/>
+              </a:rPr>
+              <a:t>13 modeli · 6 enumów</a:t>
+            </a:r>
+            <a:pPr indent="0" marL="0">
+              <a:lnSpc>
+                <a:spcPct val="112000"/>
+              </a:lnSpc>
+              <a:buNone/>
+            </a:pPr>
+            <a:r>
+              <a:rPr lang="en-US" sz="1050" dirty="0">
+                <a:solidFill>
+                  <a:srgbClr val="5F7268"/>
+                </a:solidFill>
+                <a:latin typeface="Calibri" pitchFamily="34" charset="0"/>
+                <a:ea typeface="Calibri" pitchFamily="34" charset="-122"/>
+                <a:cs typeface="Calibri" pitchFamily="34" charset="-120"/>
+              </a:rPr>
+              <a:t>  drzewo jednostek, wiele-do-wielu</a:t>
+            </a:r>
+            <a:endParaRPr lang="en-US" sz="1050" dirty="0"/>
+          </a:p>
+          <a:p>
+            <a:pPr indent="0" marL="0">
+              <a:lnSpc>
+                <a:spcPct val="112000"/>
+              </a:lnSpc>
+              <a:buNone/>
+            </a:pPr>
+            <a:r>
+              <a:rPr lang="en-US" sz="1050" b="1" dirty="0">
+                <a:solidFill>
+                  <a:srgbClr val="16241E"/>
+                </a:solidFill>
+                <a:latin typeface="Calibri" pitchFamily="34" charset="0"/>
+                <a:ea typeface="Calibri" pitchFamily="34" charset="-122"/>
+                <a:cs typeface="Calibri" pitchFamily="34" charset="-120"/>
+              </a:rPr>
+              <a:t>pg_dump</a:t>
+            </a:r>
+            <a:pPr indent="0" marL="0">
+              <a:lnSpc>
+                <a:spcPct val="112000"/>
+              </a:lnSpc>
+              <a:buNone/>
+            </a:pPr>
+            <a:r>
+              <a:rPr lang="en-US" sz="1050" dirty="0">
+                <a:solidFill>
+                  <a:srgbClr val="5F7268"/>
+                </a:solidFill>
+                <a:latin typeface="Calibri" pitchFamily="34" charset="0"/>
+                <a:ea typeface="Calibri" pitchFamily="34" charset="-122"/>
+                <a:cs typeface="Calibri" pitchFamily="34" charset="-120"/>
+              </a:rPr>
+              <a:t>  backup z timerem systemd</a:t>
+            </a:r>
+            <a:endParaRPr lang="en-US" sz="1050" dirty="0"/>
+          </a:p>
+          <a:p>
+            <a:pPr indent="0" marL="0">
+              <a:lnSpc>
+                <a:spcPct val="112000"/>
+              </a:lnSpc>
+              <a:buNone/>
+            </a:pPr>
+            <a:r>
+              <a:rPr lang="en-US" sz="1050" b="1" dirty="0">
+                <a:solidFill>
+                  <a:srgbClr val="16241E"/>
+                </a:solidFill>
+                <a:latin typeface="Calibri" pitchFamily="34" charset="0"/>
+                <a:ea typeface="Calibri" pitchFamily="34" charset="-122"/>
+                <a:cs typeface="Calibri" pitchFamily="34" charset="-120"/>
+              </a:rPr>
+              <a:t>Seed i dane demo</a:t>
+            </a:r>
+            <a:pPr indent="0" marL="0">
+              <a:lnSpc>
+                <a:spcPct val="112000"/>
+              </a:lnSpc>
+              <a:buNone/>
+            </a:pPr>
+            <a:r>
+              <a:rPr lang="en-US" sz="1050" dirty="0">
+                <a:solidFill>
+                  <a:srgbClr val="5F7268"/>
+                </a:solidFill>
+                <a:latin typeface="Calibri" pitchFamily="34" charset="0"/>
+                <a:ea typeface="Calibri" pitchFamily="34" charset="-122"/>
+                <a:cs typeface="Calibri" pitchFamily="34" charset="-120"/>
+              </a:rPr>
+              <a:t>  skrypty odtwarzają stan aplikacji</a:t>
+            </a:r>
+            <a:endParaRPr lang="en-US" sz="1050" dirty="0"/>
+          </a:p>
+        </p:txBody>
+      </p:sp>
+      <p:sp>
+        <p:nvSpPr>
+          <p:cNvPr id="24" name="Shape 22"/>
+          <p:cNvSpPr/>
+          <p:nvPr/>
+        </p:nvSpPr>
+        <p:spPr>
+          <a:xfrm>
+            <a:off x="4337304" y="3255264"/>
+            <a:ext cx="3514344" cy="1737360"/>
+          </a:xfrm>
+          <a:prstGeom prst="roundRect">
+            <a:avLst>
+              <a:gd name="adj" fmla="val 2632"/>
+            </a:avLst>
+          </a:prstGeom>
+          <a:solidFill>
+            <a:srgbClr val="F3F7F5"/>
+          </a:solidFill>
+          <a:ln w="12700">
+            <a:solidFill>
+              <a:srgbClr val="DEE8E3"/>
+            </a:solidFill>
+            <a:prstDash val="solid"/>
+          </a:ln>
+          <a:effectLst>
+            <a:outerShdw sx="100000" sy="100000" kx="0" ky="0" algn="bl" rotWithShape="0" blurRad="76200" dist="12700" dir="5400000">
+              <a:srgbClr val="BFCFC8">
+                <a:alpha val="45000"/>
+              </a:srgbClr>
+            </a:outerShdw>
+          </a:effectLst>
+        </p:spPr>
+      </p:sp>
+      <p:sp>
+        <p:nvSpPr>
+          <p:cNvPr id="25" name="Shape 23"/>
+          <p:cNvSpPr/>
+          <p:nvPr/>
+        </p:nvSpPr>
+        <p:spPr>
+          <a:xfrm>
+            <a:off x="4483608" y="3401568"/>
+            <a:ext cx="603504" cy="246888"/>
+          </a:xfrm>
+          <a:prstGeom prst="roundRect">
+            <a:avLst>
+              <a:gd name="adj" fmla="val 22222"/>
+            </a:avLst>
+          </a:prstGeom>
+          <a:solidFill>
+            <a:srgbClr val="31708A"/>
+          </a:solidFill>
+          <a:ln w="12700">
+            <a:solidFill>
+              <a:srgbClr val="31708A"/>
+            </a:solidFill>
+            <a:prstDash val="solid"/>
+          </a:ln>
+        </p:spPr>
+      </p:sp>
+      <p:sp>
+        <p:nvSpPr>
+          <p:cNvPr id="26" name="Text 24"/>
+          <p:cNvSpPr/>
+          <p:nvPr/>
+        </p:nvSpPr>
+        <p:spPr>
+          <a:xfrm>
+            <a:off x="4483608" y="3401568"/>
+            <a:ext cx="603504" cy="246888"/>
+          </a:xfrm>
+          <a:prstGeom prst="rect">
+            <a:avLst/>
+          </a:prstGeom>
+          <a:noFill/>
+          <a:ln/>
+        </p:spPr>
+        <p:txBody>
+          <a:bodyPr wrap="square" lIns="0" tIns="0" rIns="0" bIns="0" rtlCol="0" anchor="ctr"/>
+          <a:lstStyle/>
+          <a:p>
+            <a:pPr algn="ctr" indent="0" marL="0">
+              <a:buNone/>
+            </a:pPr>
+            <a:r>
+              <a:rPr lang="en-US" sz="900" b="1" dirty="0">
+                <a:solidFill>
+                  <a:srgbClr val="FFFFFF"/>
+                </a:solidFill>
+                <a:latin typeface="Calibri" pitchFamily="34" charset="0"/>
+                <a:ea typeface="Calibri" pitchFamily="34" charset="-122"/>
+                <a:cs typeface="Calibri" pitchFamily="34" charset="-120"/>
+              </a:rPr>
+              <a:t>I/O</a:t>
+            </a:r>
+            <a:endParaRPr lang="en-US" sz="900" dirty="0"/>
+          </a:p>
+        </p:txBody>
+      </p:sp>
+      <p:sp>
+        <p:nvSpPr>
+          <p:cNvPr id="27" name="Text 25"/>
+          <p:cNvSpPr/>
+          <p:nvPr/>
+        </p:nvSpPr>
+        <p:spPr>
+          <a:xfrm>
+            <a:off x="5196840" y="3383280"/>
+            <a:ext cx="2508504" cy="256032"/>
+          </a:xfrm>
+          <a:prstGeom prst="rect">
+            <a:avLst/>
+          </a:prstGeom>
+          <a:noFill/>
+          <a:ln/>
+        </p:spPr>
+        <p:txBody>
+          <a:bodyPr wrap="square" lIns="0" tIns="0" rIns="0" bIns="0" rtlCol="0" anchor="ctr"/>
+          <a:lstStyle/>
+          <a:p>
+            <a:pPr indent="0" marL="0">
+              <a:buNone/>
+            </a:pPr>
+            <a:r>
+              <a:rPr lang="en-US" sz="1300" b="1" dirty="0">
+                <a:solidFill>
+                  <a:srgbClr val="0A2E24"/>
+                </a:solidFill>
+                <a:latin typeface="Calibri" pitchFamily="34" charset="0"/>
+                <a:ea typeface="Calibri" pitchFamily="34" charset="-122"/>
+                <a:cs typeface="Calibri" pitchFamily="34" charset="-120"/>
+              </a:rPr>
+              <a:t>Formaty i integracje</a:t>
+            </a:r>
+            <a:endParaRPr lang="en-US" sz="1300" dirty="0"/>
+          </a:p>
+        </p:txBody>
+      </p:sp>
+      <p:sp>
+        <p:nvSpPr>
+          <p:cNvPr id="28" name="Text 26"/>
+          <p:cNvSpPr/>
+          <p:nvPr/>
+        </p:nvSpPr>
+        <p:spPr>
+          <a:xfrm>
+            <a:off x="4483608" y="3749040"/>
+            <a:ext cx="3221736" cy="1115568"/>
+          </a:xfrm>
+          <a:prstGeom prst="rect">
+            <a:avLst/>
+          </a:prstGeom>
+          <a:noFill/>
+          <a:ln/>
+        </p:spPr>
+        <p:txBody>
+          <a:bodyPr wrap="square" lIns="0" tIns="0" rIns="0" bIns="0" rtlCol="0" anchor="ctr"/>
+          <a:lstStyle/>
+          <a:p>
+            <a:pPr indent="0" marL="0">
+              <a:lnSpc>
+                <a:spcPct val="112000"/>
+              </a:lnSpc>
+              <a:buNone/>
+            </a:pPr>
+            <a:r>
+              <a:rPr lang="en-US" sz="1050" b="1" dirty="0">
+                <a:solidFill>
+                  <a:srgbClr val="16241E"/>
+                </a:solidFill>
+                <a:latin typeface="Calibri" pitchFamily="34" charset="0"/>
+                <a:ea typeface="Calibri" pitchFamily="34" charset="-122"/>
+                <a:cs typeface="Calibri" pitchFamily="34" charset="-120"/>
+              </a:rPr>
+              <a:t>exceljs 4</a:t>
+            </a:r>
+            <a:pPr indent="0" marL="0">
+              <a:lnSpc>
+                <a:spcPct val="112000"/>
+              </a:lnSpc>
+              <a:buNone/>
+            </a:pPr>
+            <a:r>
+              <a:rPr lang="en-US" sz="1050" dirty="0">
+                <a:solidFill>
+                  <a:srgbClr val="5F7268"/>
+                </a:solidFill>
+                <a:latin typeface="Calibri" pitchFamily="34" charset="0"/>
+                <a:ea typeface="Calibri" pitchFamily="34" charset="-122"/>
+                <a:cs typeface="Calibri" pitchFamily="34" charset="-120"/>
+              </a:rPr>
+              <a:t>  import pracowników i sprintów, eksport</a:t>
+            </a:r>
+            <a:endParaRPr lang="en-US" sz="1050" dirty="0"/>
+          </a:p>
+          <a:p>
+            <a:pPr indent="0" marL="0">
+              <a:lnSpc>
+                <a:spcPct val="112000"/>
+              </a:lnSpc>
+              <a:buNone/>
+            </a:pPr>
+            <a:r>
+              <a:rPr lang="en-US" sz="1050" b="1" dirty="0">
+                <a:solidFill>
+                  <a:srgbClr val="16241E"/>
+                </a:solidFill>
+                <a:latin typeface="Calibri" pitchFamily="34" charset="0"/>
+                <a:ea typeface="Calibri" pitchFamily="34" charset="-122"/>
+                <a:cs typeface="Calibri" pitchFamily="34" charset="-120"/>
+              </a:rPr>
+              <a:t>nodemailer 9</a:t>
+            </a:r>
+            <a:pPr indent="0" marL="0">
+              <a:lnSpc>
+                <a:spcPct val="112000"/>
+              </a:lnSpc>
+              <a:buNone/>
+            </a:pPr>
+            <a:r>
+              <a:rPr lang="en-US" sz="1050" dirty="0">
+                <a:solidFill>
+                  <a:srgbClr val="5F7268"/>
+                </a:solidFill>
+                <a:latin typeface="Calibri" pitchFamily="34" charset="0"/>
+                <a:ea typeface="Calibri" pitchFamily="34" charset="-122"/>
+                <a:cs typeface="Calibri" pitchFamily="34" charset="-120"/>
+              </a:rPr>
+              <a:t>  powiadomienia i przypomnienia przez SMTP</a:t>
+            </a:r>
+            <a:endParaRPr lang="en-US" sz="1050" dirty="0"/>
+          </a:p>
+          <a:p>
+            <a:pPr indent="0" marL="0">
+              <a:lnSpc>
+                <a:spcPct val="112000"/>
+              </a:lnSpc>
+              <a:buNone/>
+            </a:pPr>
+            <a:r>
+              <a:rPr lang="en-US" sz="1050" b="1" dirty="0">
+                <a:solidFill>
+                  <a:srgbClr val="16241E"/>
+                </a:solidFill>
+                <a:latin typeface="Calibri" pitchFamily="34" charset="0"/>
+                <a:ea typeface="Calibri" pitchFamily="34" charset="-122"/>
+                <a:cs typeface="Calibri" pitchFamily="34" charset="-120"/>
+              </a:rPr>
+              <a:t>iCal</a:t>
+            </a:r>
+            <a:pPr indent="0" marL="0">
+              <a:lnSpc>
+                <a:spcPct val="112000"/>
+              </a:lnSpc>
+              <a:buNone/>
+            </a:pPr>
+            <a:r>
+              <a:rPr lang="en-US" sz="1050" dirty="0">
+                <a:solidFill>
+                  <a:srgbClr val="5F7268"/>
+                </a:solidFill>
+                <a:latin typeface="Calibri" pitchFamily="34" charset="0"/>
+                <a:ea typeface="Calibri" pitchFamily="34" charset="-122"/>
+                <a:cs typeface="Calibri" pitchFamily="34" charset="-120"/>
+              </a:rPr>
+              <a:t>  własny generator w core, bez zależności</a:t>
+            </a:r>
+            <a:endParaRPr lang="en-US" sz="1050" dirty="0"/>
+          </a:p>
+          <a:p>
+            <a:pPr indent="0" marL="0">
+              <a:lnSpc>
+                <a:spcPct val="112000"/>
+              </a:lnSpc>
+              <a:buNone/>
+            </a:pPr>
+            <a:r>
+              <a:rPr lang="en-US" sz="1050" b="1" dirty="0">
+                <a:solidFill>
+                  <a:srgbClr val="16241E"/>
+                </a:solidFill>
+                <a:latin typeface="Calibri" pitchFamily="34" charset="0"/>
+                <a:ea typeface="Calibri" pitchFamily="34" charset="-122"/>
+                <a:cs typeface="Calibri" pitchFamily="34" charset="-120"/>
+              </a:rPr>
+              <a:t>Brak integracji zewnętrznych</a:t>
+            </a:r>
+            <a:pPr indent="0" marL="0">
+              <a:lnSpc>
+                <a:spcPct val="112000"/>
+              </a:lnSpc>
+              <a:buNone/>
+            </a:pPr>
+            <a:r>
+              <a:rPr lang="en-US" sz="1050" dirty="0">
+                <a:solidFill>
+                  <a:srgbClr val="5F7268"/>
+                </a:solidFill>
+                <a:latin typeface="Calibri" pitchFamily="34" charset="0"/>
+                <a:ea typeface="Calibri" pitchFamily="34" charset="-122"/>
+                <a:cs typeface="Calibri" pitchFamily="34" charset="-120"/>
+              </a:rPr>
+              <a:t>  szew AuthProvider gotowy pod SSO</a:t>
+            </a:r>
+            <a:endParaRPr lang="en-US" sz="1050" dirty="0"/>
+          </a:p>
+        </p:txBody>
+      </p:sp>
+      <p:sp>
+        <p:nvSpPr>
+          <p:cNvPr id="29" name="Shape 27"/>
+          <p:cNvSpPr/>
+          <p:nvPr/>
+        </p:nvSpPr>
+        <p:spPr>
+          <a:xfrm>
+            <a:off x="8125968" y="3255264"/>
+            <a:ext cx="3514344" cy="1737360"/>
+          </a:xfrm>
+          <a:prstGeom prst="roundRect">
+            <a:avLst>
+              <a:gd name="adj" fmla="val 2632"/>
+            </a:avLst>
+          </a:prstGeom>
+          <a:solidFill>
+            <a:srgbClr val="F3F7F5"/>
+          </a:solidFill>
+          <a:ln w="12700">
+            <a:solidFill>
+              <a:srgbClr val="DEE8E3"/>
+            </a:solidFill>
+            <a:prstDash val="solid"/>
+          </a:ln>
+          <a:effectLst>
+            <a:outerShdw sx="100000" sy="100000" kx="0" ky="0" algn="bl" rotWithShape="0" blurRad="76200" dist="12700" dir="5400000">
+              <a:srgbClr val="BFCFC8">
+                <a:alpha val="45000"/>
+              </a:srgbClr>
+            </a:outerShdw>
+          </a:effectLst>
+        </p:spPr>
+      </p:sp>
+      <p:sp>
+        <p:nvSpPr>
+          <p:cNvPr id="30" name="Shape 28"/>
+          <p:cNvSpPr/>
+          <p:nvPr/>
+        </p:nvSpPr>
+        <p:spPr>
+          <a:xfrm>
+            <a:off x="8272272" y="3401568"/>
+            <a:ext cx="603504" cy="246888"/>
+          </a:xfrm>
+          <a:prstGeom prst="roundRect">
+            <a:avLst>
+              <a:gd name="adj" fmla="val 22222"/>
+            </a:avLst>
+          </a:prstGeom>
+          <a:solidFill>
+            <a:srgbClr val="31708A"/>
+          </a:solidFill>
+          <a:ln w="12700">
+            <a:solidFill>
+              <a:srgbClr val="31708A"/>
+            </a:solidFill>
+            <a:prstDash val="solid"/>
+          </a:ln>
+        </p:spPr>
+      </p:sp>
+      <p:sp>
+        <p:nvSpPr>
+          <p:cNvPr id="31" name="Text 29"/>
+          <p:cNvSpPr/>
+          <p:nvPr/>
+        </p:nvSpPr>
+        <p:spPr>
+          <a:xfrm>
+            <a:off x="8272272" y="3401568"/>
+            <a:ext cx="603504" cy="246888"/>
+          </a:xfrm>
+          <a:prstGeom prst="rect">
+            <a:avLst/>
+          </a:prstGeom>
+          <a:noFill/>
+          <a:ln/>
+        </p:spPr>
+        <p:txBody>
+          <a:bodyPr wrap="square" lIns="0" tIns="0" rIns="0" bIns="0" rtlCol="0" anchor="ctr"/>
+          <a:lstStyle/>
+          <a:p>
+            <a:pPr algn="ctr" indent="0" marL="0">
+              <a:buNone/>
+            </a:pPr>
+            <a:r>
+              <a:rPr lang="en-US" sz="900" b="1" dirty="0">
+                <a:solidFill>
+                  <a:srgbClr val="FFFFFF"/>
+                </a:solidFill>
+                <a:latin typeface="Calibri" pitchFamily="34" charset="0"/>
+                <a:ea typeface="Calibri" pitchFamily="34" charset="-122"/>
+                <a:cs typeface="Calibri" pitchFamily="34" charset="-120"/>
+              </a:rPr>
+              <a:t>OPS</a:t>
+            </a:r>
+            <a:endParaRPr lang="en-US" sz="900" dirty="0"/>
+          </a:p>
+        </p:txBody>
+      </p:sp>
+      <p:sp>
+        <p:nvSpPr>
+          <p:cNvPr id="32" name="Text 30"/>
+          <p:cNvSpPr/>
+          <p:nvPr/>
+        </p:nvSpPr>
+        <p:spPr>
+          <a:xfrm>
+            <a:off x="8985504" y="3383280"/>
+            <a:ext cx="2508504" cy="256032"/>
+          </a:xfrm>
+          <a:prstGeom prst="rect">
+            <a:avLst/>
+          </a:prstGeom>
+          <a:noFill/>
+          <a:ln/>
+        </p:spPr>
+        <p:txBody>
+          <a:bodyPr wrap="square" lIns="0" tIns="0" rIns="0" bIns="0" rtlCol="0" anchor="ctr"/>
+          <a:lstStyle/>
+          <a:p>
+            <a:pPr indent="0" marL="0">
+              <a:buNone/>
+            </a:pPr>
+            <a:r>
+              <a:rPr lang="en-US" sz="1300" b="1" dirty="0">
+                <a:solidFill>
+                  <a:srgbClr val="0A2E24"/>
+                </a:solidFill>
+                <a:latin typeface="Calibri" pitchFamily="34" charset="0"/>
+                <a:ea typeface="Calibri" pitchFamily="34" charset="-122"/>
+                <a:cs typeface="Calibri" pitchFamily="34" charset="-120"/>
+              </a:rPr>
+              <a:t>Uruchomienie</a:t>
+            </a:r>
+            <a:endParaRPr lang="en-US" sz="1300" dirty="0"/>
+          </a:p>
+        </p:txBody>
+      </p:sp>
+      <p:sp>
+        <p:nvSpPr>
+          <p:cNvPr id="33" name="Text 31"/>
+          <p:cNvSpPr/>
+          <p:nvPr/>
+        </p:nvSpPr>
+        <p:spPr>
+          <a:xfrm>
+            <a:off x="8272272" y="3749040"/>
+            <a:ext cx="3221736" cy="1115568"/>
+          </a:xfrm>
+          <a:prstGeom prst="rect">
+            <a:avLst/>
+          </a:prstGeom>
+          <a:noFill/>
+          <a:ln/>
+        </p:spPr>
+        <p:txBody>
+          <a:bodyPr wrap="square" lIns="0" tIns="0" rIns="0" bIns="0" rtlCol="0" anchor="ctr"/>
+          <a:lstStyle/>
+          <a:p>
+            <a:pPr indent="0" marL="0">
+              <a:lnSpc>
+                <a:spcPct val="112000"/>
+              </a:lnSpc>
+              <a:buNone/>
+            </a:pPr>
+            <a:r>
+              <a:rPr lang="en-US" sz="1050" b="1" dirty="0">
+                <a:solidFill>
+                  <a:srgbClr val="16241E"/>
+                </a:solidFill>
+                <a:latin typeface="Calibri" pitchFamily="34" charset="0"/>
+                <a:ea typeface="Calibri" pitchFamily="34" charset="-122"/>
+                <a:cs typeface="Calibri" pitchFamily="34" charset="-120"/>
+              </a:rPr>
+              <a:t>Docker Compose</a:t>
+            </a:r>
+            <a:pPr indent="0" marL="0">
+              <a:lnSpc>
+                <a:spcPct val="112000"/>
+              </a:lnSpc>
+              <a:buNone/>
+            </a:pPr>
+            <a:r>
+              <a:rPr lang="en-US" sz="1050" dirty="0">
+                <a:solidFill>
+                  <a:srgbClr val="5F7268"/>
+                </a:solidFill>
+                <a:latin typeface="Calibri" pitchFamily="34" charset="0"/>
+                <a:ea typeface="Calibri" pitchFamily="34" charset="-122"/>
+                <a:cs typeface="Calibri" pitchFamily="34" charset="-120"/>
+              </a:rPr>
+              <a:t>  node:22-slim + postgres:16</a:t>
+            </a:r>
+            <a:endParaRPr lang="en-US" sz="1050" dirty="0"/>
+          </a:p>
+          <a:p>
+            <a:pPr indent="0" marL="0">
+              <a:lnSpc>
+                <a:spcPct val="112000"/>
+              </a:lnSpc>
+              <a:buNone/>
+            </a:pPr>
+            <a:r>
+              <a:rPr lang="en-US" sz="1050" b="1" dirty="0">
+                <a:solidFill>
+                  <a:srgbClr val="16241E"/>
+                </a:solidFill>
+                <a:latin typeface="Calibri" pitchFamily="34" charset="0"/>
+                <a:ea typeface="Calibri" pitchFamily="34" charset="-122"/>
+                <a:cs typeface="Calibri" pitchFamily="34" charset="-120"/>
+              </a:rPr>
+              <a:t>Caddy 2</a:t>
+            </a:r>
+            <a:pPr indent="0" marL="0">
+              <a:lnSpc>
+                <a:spcPct val="112000"/>
+              </a:lnSpc>
+              <a:buNone/>
+            </a:pPr>
+            <a:r>
+              <a:rPr lang="en-US" sz="1050" dirty="0">
+                <a:solidFill>
+                  <a:srgbClr val="5F7268"/>
+                </a:solidFill>
+                <a:latin typeface="Calibri" pitchFamily="34" charset="0"/>
+                <a:ea typeface="Calibri" pitchFamily="34" charset="-122"/>
+                <a:cs typeface="Calibri" pitchFamily="34" charset="-120"/>
+              </a:rPr>
+              <a:t>  TLS z automatycznym certyfikatem</a:t>
+            </a:r>
+            <a:endParaRPr lang="en-US" sz="1050" dirty="0"/>
+          </a:p>
+          <a:p>
+            <a:pPr indent="0" marL="0">
+              <a:lnSpc>
+                <a:spcPct val="112000"/>
+              </a:lnSpc>
+              <a:buNone/>
+            </a:pPr>
+            <a:r>
+              <a:rPr lang="en-US" sz="1050" b="1" dirty="0">
+                <a:solidFill>
+                  <a:srgbClr val="16241E"/>
+                </a:solidFill>
+                <a:latin typeface="Calibri" pitchFamily="34" charset="0"/>
+                <a:ea typeface="Calibri" pitchFamily="34" charset="-122"/>
+                <a:cs typeface="Calibri" pitchFamily="34" charset="-120"/>
+              </a:rPr>
+              <a:t>GitHub Actions</a:t>
+            </a:r>
+            <a:pPr indent="0" marL="0">
+              <a:lnSpc>
+                <a:spcPct val="112000"/>
+              </a:lnSpc>
+              <a:buNone/>
+            </a:pPr>
+            <a:r>
+              <a:rPr lang="en-US" sz="1050" dirty="0">
+                <a:solidFill>
+                  <a:srgbClr val="5F7268"/>
+                </a:solidFill>
+                <a:latin typeface="Calibri" pitchFamily="34" charset="0"/>
+                <a:ea typeface="Calibri" pitchFamily="34" charset="-122"/>
+                <a:cs typeface="Calibri" pitchFamily="34" charset="-120"/>
+              </a:rPr>
+              <a:t>  te same kroki co lokalna weryfikacja</a:t>
+            </a:r>
+            <a:endParaRPr lang="en-US" sz="1050" dirty="0"/>
+          </a:p>
+          <a:p>
+            <a:pPr indent="0" marL="0">
+              <a:lnSpc>
+                <a:spcPct val="112000"/>
+              </a:lnSpc>
+              <a:buNone/>
+            </a:pPr>
+            <a:r>
+              <a:rPr lang="en-US" sz="1050" b="1" dirty="0">
+                <a:solidFill>
+                  <a:srgbClr val="16241E"/>
+                </a:solidFill>
+                <a:latin typeface="Calibri" pitchFamily="34" charset="0"/>
+                <a:ea typeface="Calibri" pitchFamily="34" charset="-122"/>
+                <a:cs typeface="Calibri" pitchFamily="34" charset="-120"/>
+              </a:rPr>
+              <a:t>On-premise</a:t>
+            </a:r>
+            <a:pPr indent="0" marL="0">
+              <a:lnSpc>
+                <a:spcPct val="112000"/>
+              </a:lnSpc>
+              <a:buNone/>
+            </a:pPr>
+            <a:r>
+              <a:rPr lang="en-US" sz="1050" dirty="0">
+                <a:solidFill>
+                  <a:srgbClr val="5F7268"/>
+                </a:solidFill>
+                <a:latin typeface="Calibri" pitchFamily="34" charset="0"/>
+                <a:ea typeface="Calibri" pitchFamily="34" charset="-122"/>
+                <a:cs typeface="Calibri" pitchFamily="34" charset="-120"/>
+              </a:rPr>
+              <a:t>  jedna maszyna, bez chmury</a:t>
+            </a:r>
+            <a:endParaRPr lang="en-US" sz="1050" dirty="0"/>
+          </a:p>
+          <a:p>
+            <a:pPr indent="0" marL="0">
+              <a:lnSpc>
+                <a:spcPct val="112000"/>
+              </a:lnSpc>
+              <a:buNone/>
+            </a:pPr>
+            <a:r>
+              <a:rPr lang="en-US" sz="1050" b="1" dirty="0">
+                <a:solidFill>
+                  <a:srgbClr val="16241E"/>
+                </a:solidFill>
+                <a:latin typeface="Calibri" pitchFamily="34" charset="0"/>
+                <a:ea typeface="Calibri" pitchFamily="34" charset="-122"/>
+                <a:cs typeface="Calibri" pitchFamily="34" charset="-120"/>
+              </a:rPr>
+              <a:t>/api/health</a:t>
+            </a:r>
+            <a:pPr indent="0" marL="0">
+              <a:lnSpc>
+                <a:spcPct val="112000"/>
+              </a:lnSpc>
+              <a:buNone/>
+            </a:pPr>
+            <a:r>
+              <a:rPr lang="en-US" sz="1050" dirty="0">
+                <a:solidFill>
+                  <a:srgbClr val="5F7268"/>
+                </a:solidFill>
+                <a:latin typeface="Calibri" pitchFamily="34" charset="0"/>
+                <a:ea typeface="Calibri" pitchFamily="34" charset="-122"/>
+                <a:cs typeface="Calibri" pitchFamily="34" charset="-120"/>
+              </a:rPr>
+              <a:t>  sonda dla monitoringu (NFR-2)</a:t>
+            </a:r>
+            <a:endParaRPr lang="en-US" sz="1050" dirty="0"/>
+          </a:p>
+        </p:txBody>
+      </p:sp>
+      <p:sp>
+        <p:nvSpPr>
+          <p:cNvPr id="34" name="Shape 32"/>
+          <p:cNvSpPr/>
+          <p:nvPr/>
+        </p:nvSpPr>
+        <p:spPr>
+          <a:xfrm>
+            <a:off x="548640" y="5340096"/>
+            <a:ext cx="11091672" cy="923544"/>
+          </a:xfrm>
+          <a:prstGeom prst="roundRect">
+            <a:avLst>
+              <a:gd name="adj" fmla="val 4950"/>
+            </a:avLst>
+          </a:prstGeom>
+          <a:solidFill>
+            <a:srgbClr val="F3F7F5"/>
+          </a:solidFill>
+          <a:ln w="12700">
+            <a:solidFill>
+              <a:srgbClr val="DEE8E3"/>
+            </a:solidFill>
+            <a:prstDash val="solid"/>
+          </a:ln>
+          <a:effectLst>
+            <a:outerShdw sx="100000" sy="100000" kx="0" ky="0" algn="bl" rotWithShape="0" blurRad="76200" dist="12700" dir="5400000">
+              <a:srgbClr val="BFCFC8">
+                <a:alpha val="45000"/>
+              </a:srgbClr>
+            </a:outerShdw>
+          </a:effectLst>
+        </p:spPr>
+      </p:sp>
+      <p:sp>
+        <p:nvSpPr>
+          <p:cNvPr id="35" name="Text 33"/>
+          <p:cNvSpPr/>
+          <p:nvPr/>
+        </p:nvSpPr>
+        <p:spPr>
+          <a:xfrm>
+            <a:off x="731520" y="5468112"/>
+            <a:ext cx="2194560" cy="237744"/>
+          </a:xfrm>
+          <a:prstGeom prst="rect">
+            <a:avLst/>
+          </a:prstGeom>
+          <a:noFill/>
+          <a:ln/>
+        </p:spPr>
+        <p:txBody>
+          <a:bodyPr wrap="square" lIns="0" tIns="0" rIns="0" bIns="0" rtlCol="0" anchor="ctr"/>
+          <a:lstStyle/>
+          <a:p>
+            <a:pPr indent="0" marL="0">
+              <a:buNone/>
+            </a:pPr>
+            <a:r>
+              <a:rPr lang="en-US" sz="1250" b="1" dirty="0">
+                <a:solidFill>
+                  <a:srgbClr val="007A53"/>
+                </a:solidFill>
+                <a:latin typeface="Calibri" pitchFamily="34" charset="0"/>
+                <a:ea typeface="Calibri" pitchFamily="34" charset="-122"/>
+                <a:cs typeface="Calibri" pitchFamily="34" charset="-120"/>
+              </a:rPr>
+              <a:t>Świadomie pominięte</a:t>
+            </a:r>
+            <a:endParaRPr lang="en-US" sz="1250" dirty="0"/>
+          </a:p>
+        </p:txBody>
+      </p:sp>
+      <p:sp>
+        <p:nvSpPr>
+          <p:cNvPr id="36" name="Text 34"/>
+          <p:cNvSpPr/>
+          <p:nvPr/>
+        </p:nvSpPr>
+        <p:spPr>
+          <a:xfrm>
+            <a:off x="3017520" y="5486400"/>
+            <a:ext cx="8439912" cy="640080"/>
+          </a:xfrm>
+          <a:prstGeom prst="rect">
+            <a:avLst/>
+          </a:prstGeom>
+          <a:noFill/>
+          <a:ln/>
+        </p:spPr>
+        <p:txBody>
+          <a:bodyPr wrap="square" lIns="0" tIns="0" rIns="0" bIns="0" rtlCol="0" anchor="ctr"/>
+          <a:lstStyle/>
+          <a:p>
+            <a:pPr indent="0" marL="0">
+              <a:lnSpc>
+                <a:spcPct val="112000"/>
+              </a:lnSpc>
+              <a:buNone/>
+            </a:pPr>
+            <a:r>
+              <a:rPr lang="en-US" sz="1050" b="1" dirty="0">
+                <a:solidFill>
+                  <a:srgbClr val="16241E"/>
+                </a:solidFill>
+                <a:latin typeface="Calibri" pitchFamily="34" charset="0"/>
+                <a:ea typeface="Calibri" pitchFamily="34" charset="-122"/>
+                <a:cs typeface="Calibri" pitchFamily="34" charset="-120"/>
+              </a:rPr>
+              <a:t>WebSockety</a:t>
+            </a:r>
+            <a:pPr indent="0" marL="0">
+              <a:lnSpc>
+                <a:spcPct val="112000"/>
+              </a:lnSpc>
+              <a:buNone/>
+            </a:pPr>
+            <a:r>
+              <a:rPr lang="en-US" sz="1050" dirty="0">
+                <a:solidFill>
+                  <a:srgbClr val="5F7268"/>
+                </a:solidFill>
+                <a:latin typeface="Calibri" pitchFamily="34" charset="0"/>
+                <a:ea typeface="Calibri" pitchFamily="34" charset="-122"/>
+                <a:cs typeface="Calibri" pitchFamily="34" charset="-120"/>
+              </a:rPr>
+              <a:t> — odświeżenie po zapisie daje licznik &lt;1 s.   </a:t>
+            </a:r>
+            <a:pPr indent="0" marL="0">
+              <a:lnSpc>
+                <a:spcPct val="112000"/>
+              </a:lnSpc>
+              <a:buNone/>
+            </a:pPr>
+            <a:r>
+              <a:rPr lang="en-US" sz="1050" b="1" dirty="0">
+                <a:solidFill>
+                  <a:srgbClr val="16241E"/>
+                </a:solidFill>
+                <a:latin typeface="Calibri" pitchFamily="34" charset="0"/>
+                <a:ea typeface="Calibri" pitchFamily="34" charset="-122"/>
+                <a:cs typeface="Calibri" pitchFamily="34" charset="-120"/>
+              </a:rPr>
+              <a:t>Redis i kolejki</a:t>
+            </a:r>
+            <a:pPr indent="0" marL="0">
+              <a:lnSpc>
+                <a:spcPct val="112000"/>
+              </a:lnSpc>
+              <a:buNone/>
+            </a:pPr>
+            <a:r>
+              <a:rPr lang="en-US" sz="1050" dirty="0">
+                <a:solidFill>
+                  <a:srgbClr val="5F7268"/>
+                </a:solidFill>
+                <a:latin typeface="Calibri" pitchFamily="34" charset="0"/>
+                <a:ea typeface="Calibri" pitchFamily="34" charset="-122"/>
+                <a:cs typeface="Calibri" pitchFamily="34" charset="-120"/>
+              </a:rPr>
+              <a:t> — scheduler Nest wystarcza przy 300 użytkownikach.   </a:t>
+            </a:r>
+            <a:pPr indent="0" marL="0">
+              <a:lnSpc>
+                <a:spcPct val="112000"/>
+              </a:lnSpc>
+              <a:buNone/>
+            </a:pPr>
+            <a:r>
+              <a:rPr lang="en-US" sz="1050" b="1" dirty="0">
+                <a:solidFill>
+                  <a:srgbClr val="16241E"/>
+                </a:solidFill>
+                <a:latin typeface="Calibri" pitchFamily="34" charset="0"/>
+                <a:ea typeface="Calibri" pitchFamily="34" charset="-122"/>
+                <a:cs typeface="Calibri" pitchFamily="34" charset="-120"/>
+              </a:rPr>
+              <a:t>Mikroserwisy</a:t>
+            </a:r>
+            <a:pPr indent="0" marL="0">
+              <a:lnSpc>
+                <a:spcPct val="112000"/>
+              </a:lnSpc>
+              <a:buNone/>
+            </a:pPr>
+            <a:r>
+              <a:rPr lang="en-US" sz="1050" dirty="0">
+                <a:solidFill>
+                  <a:srgbClr val="5F7268"/>
+                </a:solidFill>
+                <a:latin typeface="Calibri" pitchFamily="34" charset="0"/>
+                <a:ea typeface="Calibri" pitchFamily="34" charset="-122"/>
+                <a:cs typeface="Calibri" pitchFamily="34" charset="-120"/>
+              </a:rPr>
+              <a:t> — jeden monolit API skaluje się w tej skali.</a:t>
+            </a:r>
+            <a:endParaRPr lang="en-US" sz="1050" dirty="0"/>
+          </a:p>
+          <a:p>
+            <a:pPr indent="0" marL="0">
+              <a:lnSpc>
+                <a:spcPct val="112000"/>
+              </a:lnSpc>
+              <a:buNone/>
+            </a:pPr>
+            <a:r>
+              <a:rPr lang="en-US" sz="1050" b="1" dirty="0">
+                <a:solidFill>
+                  <a:srgbClr val="16241E"/>
+                </a:solidFill>
+                <a:latin typeface="Calibri" pitchFamily="34" charset="0"/>
+                <a:ea typeface="Calibri" pitchFamily="34" charset="-122"/>
+                <a:cs typeface="Calibri" pitchFamily="34" charset="-120"/>
+              </a:rPr>
+              <a:t>AD/SSO, TETA, JIRA</a:t>
+            </a:r>
+            <a:pPr indent="0" marL="0">
+              <a:lnSpc>
+                <a:spcPct val="112000"/>
+              </a:lnSpc>
+              <a:buNone/>
+            </a:pPr>
+            <a:r>
+              <a:rPr lang="en-US" sz="1050" dirty="0">
+                <a:solidFill>
+                  <a:srgbClr val="5F7268"/>
+                </a:solidFill>
+                <a:latin typeface="Calibri" pitchFamily="34" charset="0"/>
+                <a:ea typeface="Calibri" pitchFamily="34" charset="-122"/>
+                <a:cs typeface="Calibri" pitchFamily="34" charset="-120"/>
+              </a:rPr>
+              <a:t> — poza zakresem tej wersji; w kodzie czeka szew AuthProvider, więc dołożenie OIDC nie wymaga przebudowy.</a:t>
+            </a:r>
+            <a:endParaRPr lang="en-US" sz="1050" dirty="0"/>
+          </a:p>
+        </p:txBody>
+      </p:sp>
+    </p:spTree>
+  </p:cSld>
+  <p:clrMapOvr>
+    <a:masterClrMapping/>
+  </p:clrMapOvr>
+</p:sld>
+</file>
+
 <file path=ppt/theme/theme1.xml><?xml version="1.0" encoding="utf-8"?>
 <a:theme xmlns:a="http://schemas.openxmlformats.org/drawingml/2006/main" name="Office Theme">
   <a:themeElements>

</xml_diff>